<commit_message>
Update final report generation to use version 5 and add new module structure figure
- Changed the input markdown file from `final-report-v4.md` to `final-report-v5.md`.
- Updated figure mapping to reflect new figure order and added a new figure for module structure.
- Added HTML and PPTX generation functions for the new module structure figure.
- Updated the final report DOCX file to include changes and new figures.
- Updated existing PPTX figures to reflect new content.
</commit_message>
<xml_diff>
--- a/06-final-report/figures/final-figures.pptx
+++ b/06-final-report/figures/final-figures.pptx
@@ -13,9 +13,10 @@
     <p:sldId id="261" r:id="rId7"/>
     <p:sldId id="262" r:id="rId8"/>
     <p:sldId id="263" r:id="rId9"/>
+    <p:sldId id="264" r:id="rId10"/>
   </p:sldIdLst>
   <p:notesMasterIdLst>
-    <p:notesMasterId r:id="rId10"/>
+    <p:notesMasterId r:id="rId11"/>
   </p:notesMasterIdLst>
   <p:sldSz cx="12192000" cy="6858000"/>
   <p:notesSz cx="6858000" cy="12192000"/>
@@ -2524,6 +2525,94 @@
 </p:notes>
 </file>
 
+<file path=ppt/notesSlides/notesSlide9.xml><?xml version="1.0" encoding="utf-8"?>
+<p:notes xmlns:a="http://schemas.openxmlformats.org/drawingml/2006/main" xmlns:r="http://schemas.openxmlformats.org/officeDocument/2006/relationships" xmlns:p="http://schemas.openxmlformats.org/presentationml/2006/main">
+  <p:cSld>
+    <p:spTree>
+      <p:nvGrpSpPr>
+        <p:cNvPr id="1" name=""/>
+        <p:cNvGrpSpPr/>
+        <p:nvPr/>
+      </p:nvGrpSpPr>
+      <p:grpSpPr>
+        <a:xfrm>
+          <a:off x="0" y="0"/>
+          <a:ext cx="0" cy="0"/>
+          <a:chOff x="0" y="0"/>
+          <a:chExt cx="0" cy="0"/>
+        </a:xfrm>
+      </p:grpSpPr>
+      <p:sp>
+        <p:nvSpPr>
+          <p:cNvPr id="2" name="Slide Image Placeholder 1"/>
+          <p:cNvSpPr>
+            <a:spLocks noGrp="1" noRot="1" noChangeAspect="1"/>
+          </p:cNvSpPr>
+          <p:nvPr>
+            <p:ph type="sldImg"/>
+          </p:nvPr>
+        </p:nvSpPr>
+        <p:spPr/>
+      </p:sp>
+      <p:sp>
+        <p:nvSpPr>
+          <p:cNvPr id="3" name="Notes Placeholder 2"/>
+          <p:cNvSpPr>
+            <a:spLocks noGrp="1"/>
+          </p:cNvSpPr>
+          <p:nvPr>
+            <p:ph type="body" idx="1"/>
+          </p:nvPr>
+        </p:nvSpPr>
+        <p:spPr/>
+        <p:txBody>
+          <a:bodyPr/>
+          <a:lstStyle/>
+          <a:p>
+            <a:r>
+              <a:rPr lang="en-US" dirty="0"/>
+              <a:t/>
+            </a:r>
+            <a:endParaRPr lang="en-US" dirty="0"/>
+          </a:p>
+        </p:txBody>
+      </p:sp>
+      <p:sp>
+        <p:nvSpPr>
+          <p:cNvPr id="4" name="Slide Number Placeholder 3"/>
+          <p:cNvSpPr>
+            <a:spLocks noGrp="1"/>
+          </p:cNvSpPr>
+          <p:nvPr>
+            <p:ph type="sldNum" sz="quarter" idx="10"/>
+          </p:nvPr>
+        </p:nvSpPr>
+        <p:spPr/>
+        <p:txBody>
+          <a:bodyPr/>
+          <a:lstStyle/>
+          <a:p>
+            <a:fld id="{F7021451-1387-4CA6-816F-3879F97B5CBC}" type="slidenum">
+              <a:rPr lang="en-US"/>
+              <a:t>9</a:t>
+            </a:fld>
+            <a:endParaRPr lang="en-US"/>
+          </a:p>
+        </p:txBody>
+      </p:sp>
+    </p:spTree>
+    <p:extLst>
+      <p:ext uri="{BB962C8B-B14F-4D97-AF65-F5344CB8AC3E}">
+        <p14:creationId xmlns:p14="http://schemas.microsoft.com/office/powerpoint/2010/main" val="1024086991"/>
+      </p:ext>
+    </p:extLst>
+  </p:cSld>
+  <p:clrMapOvr>
+    <a:masterClrMapping/>
+  </p:clrMapOvr>
+</p:notes>
+</file>
+
 <file path=ppt/slideLayouts/slideLayout1.xml><?xml version="1.0" encoding="utf-8"?>
 <p:sldLayout xmlns:a="http://schemas.openxmlformats.org/drawingml/2006/main" xmlns:r="http://schemas.openxmlformats.org/officeDocument/2006/relationships" xmlns:p="http://schemas.openxmlformats.org/presentationml/2006/main" preserve="1">
   <p:cSld name="DEFAULT">
@@ -9698,6 +9787,980 @@
               <a:t>결과 측정: 평균 대기시간 · JFI · 요청 유형별 응답시간 · JSON 로그 기록</a:t>
             </a:r>
             <a:endParaRPr lang="en-US" sz="1000" dirty="0"/>
+          </a:p>
+        </p:txBody>
+      </p:sp>
+    </p:spTree>
+  </p:cSld>
+  <p:clrMapOvr>
+    <a:masterClrMapping/>
+  </p:clrMapOvr>
+</p:sld>
+</file>
+
+<file path=ppt/slides/slide9.xml><?xml version="1.0" encoding="utf-8"?>
+<p:sld xmlns:a="http://schemas.openxmlformats.org/drawingml/2006/main" xmlns:r="http://schemas.openxmlformats.org/officeDocument/2006/relationships" xmlns:p="http://schemas.openxmlformats.org/presentationml/2006/main">
+  <p:cSld name="Slide 9">
+    <p:spTree>
+      <p:nvGrpSpPr>
+        <p:cNvPr id="1" name=""/>
+        <p:cNvGrpSpPr/>
+        <p:nvPr/>
+      </p:nvGrpSpPr>
+      <p:grpSpPr>
+        <a:xfrm>
+          <a:off x="0" y="0"/>
+          <a:ext cx="0" cy="0"/>
+          <a:chOff x="0" y="0"/>
+          <a:chExt cx="0" cy="0"/>
+        </a:xfrm>
+      </p:grpSpPr>
+      <p:sp>
+        <p:nvSpPr>
+          <p:cNvPr id="2" name="Text 0"/>
+          <p:cNvSpPr/>
+          <p:nvPr/>
+        </p:nvSpPr>
+        <p:spPr>
+          <a:xfrm>
+            <a:off x="274320" y="91440"/>
+            <a:ext cx="8595360" cy="457200"/>
+          </a:xfrm>
+          <a:prstGeom prst="rect">
+            <a:avLst/>
+          </a:prstGeom>
+          <a:noFill/>
+          <a:ln/>
+        </p:spPr>
+        <p:txBody>
+          <a:bodyPr wrap="square" rtlCol="0" anchor="ctr"/>
+          <a:lstStyle/>
+          <a:p>
+            <a:pPr indent="0" marL="0">
+              <a:buNone/>
+            </a:pPr>
+            <a:r>
+              <a:rPr lang="en-US" sz="1800" b="1" dirty="0">
+                <a:solidFill>
+                  <a:srgbClr val="1E293B"/>
+                </a:solidFill>
+                <a:latin typeface="맑은 고딕" pitchFamily="34" charset="0"/>
+                <a:ea typeface="맑은 고딕" pitchFamily="34" charset="-122"/>
+                <a:cs typeface="맑은 고딕" pitchFamily="34" charset="-120"/>
+              </a:rPr>
+              <a:t>그림 3. 모듈 구조도 (Module Structure)</a:t>
+            </a:r>
+            <a:endParaRPr lang="en-US" sz="1800" dirty="0"/>
+          </a:p>
+        </p:txBody>
+      </p:sp>
+      <p:sp>
+        <p:nvSpPr>
+          <p:cNvPr id="3" name="Shape 1"/>
+          <p:cNvSpPr/>
+          <p:nvPr/>
+        </p:nvSpPr>
+        <p:spPr>
+          <a:xfrm>
+            <a:off x="3474720" y="685800"/>
+            <a:ext cx="2194560" cy="502920"/>
+          </a:xfrm>
+          <a:prstGeom prst="roundRect">
+            <a:avLst>
+              <a:gd name="adj" fmla="val 14545"/>
+            </a:avLst>
+          </a:prstGeom>
+          <a:solidFill>
+            <a:srgbClr val="2563EB">
+              <a:alpha val="15000"/>
+            </a:srgbClr>
+          </a:solidFill>
+          <a:ln w="25400">
+            <a:solidFill>
+              <a:srgbClr val="2563EB"/>
+            </a:solidFill>
+            <a:prstDash val="solid"/>
+          </a:ln>
+        </p:spPr>
+      </p:sp>
+      <p:sp>
+        <p:nvSpPr>
+          <p:cNvPr id="4" name="Text 2"/>
+          <p:cNvSpPr/>
+          <p:nvPr/>
+        </p:nvSpPr>
+        <p:spPr>
+          <a:xfrm>
+            <a:off x="3474720" y="685800"/>
+            <a:ext cx="2194560" cy="502920"/>
+          </a:xfrm>
+          <a:prstGeom prst="rect">
+            <a:avLst/>
+          </a:prstGeom>
+          <a:noFill/>
+          <a:ln/>
+        </p:spPr>
+        <p:txBody>
+          <a:bodyPr wrap="square" rtlCol="0" anchor="ctr"/>
+          <a:lstStyle/>
+          <a:p>
+            <a:pPr algn="ctr" indent="0" marL="0">
+              <a:buNone/>
+            </a:pPr>
+            <a:r>
+              <a:rPr lang="en-US" sz="1100" b="1" dirty="0">
+                <a:solidFill>
+                  <a:srgbClr val="2563EB"/>
+                </a:solidFill>
+                <a:latin typeface="맑은 고딕" pitchFamily="34" charset="0"/>
+                <a:ea typeface="맑은 고딕" pitchFamily="34" charset="-122"/>
+                <a:cs typeface="맑은 고딕" pitchFamily="34" charset="-120"/>
+              </a:rPr>
+              <a:t>server.js</a:t>
+            </a:r>
+            <a:endParaRPr lang="en-US" sz="1100" dirty="0"/>
+          </a:p>
+          <a:p>
+            <a:pPr algn="ctr" indent="0" marL="0">
+              <a:buNone/>
+            </a:pPr>
+            <a:r>
+              <a:rPr lang="en-US" sz="1100" b="1" dirty="0">
+                <a:solidFill>
+                  <a:srgbClr val="2563EB"/>
+                </a:solidFill>
+                <a:latin typeface="맑은 고딕" pitchFamily="34" charset="0"/>
+                <a:ea typeface="맑은 고딕" pitchFamily="34" charset="-122"/>
+                <a:cs typeface="맑은 고딕" pitchFamily="34" charset="-120"/>
+              </a:rPr>
+              <a:t>(진입점)</a:t>
+            </a:r>
+            <a:endParaRPr lang="en-US" sz="1100" dirty="0"/>
+          </a:p>
+        </p:txBody>
+      </p:sp>
+      <p:sp>
+        <p:nvSpPr>
+          <p:cNvPr id="5" name="Shape 3"/>
+          <p:cNvSpPr/>
+          <p:nvPr/>
+        </p:nvSpPr>
+        <p:spPr>
+          <a:xfrm>
+            <a:off x="274320" y="1828800"/>
+            <a:ext cx="1554480" cy="822960"/>
+          </a:xfrm>
+          <a:prstGeom prst="roundRect">
+            <a:avLst>
+              <a:gd name="adj" fmla="val 8889"/>
+            </a:avLst>
+          </a:prstGeom>
+          <a:solidFill>
+            <a:srgbClr val="059669">
+              <a:alpha val="12000"/>
+            </a:srgbClr>
+          </a:solidFill>
+          <a:ln w="19050">
+            <a:solidFill>
+              <a:srgbClr val="059669"/>
+            </a:solidFill>
+            <a:prstDash val="solid"/>
+          </a:ln>
+        </p:spPr>
+      </p:sp>
+      <p:sp>
+        <p:nvSpPr>
+          <p:cNvPr id="6" name="Text 4"/>
+          <p:cNvSpPr/>
+          <p:nvPr/>
+        </p:nvSpPr>
+        <p:spPr>
+          <a:xfrm>
+            <a:off x="274320" y="1828800"/>
+            <a:ext cx="1554480" cy="822960"/>
+          </a:xfrm>
+          <a:prstGeom prst="rect">
+            <a:avLst/>
+          </a:prstGeom>
+          <a:noFill/>
+          <a:ln/>
+        </p:spPr>
+        <p:txBody>
+          <a:bodyPr wrap="square" rtlCol="0" anchor="ctr"/>
+          <a:lstStyle/>
+          <a:p>
+            <a:pPr algn="ctr" indent="0" marL="0">
+              <a:buNone/>
+            </a:pPr>
+            <a:r>
+              <a:rPr lang="en-US" sz="900" b="1" dirty="0">
+                <a:solidFill>
+                  <a:srgbClr val="059669"/>
+                </a:solidFill>
+                <a:latin typeface="맑은 고딕" pitchFamily="34" charset="0"/>
+                <a:ea typeface="맑은 고딕" pitchFamily="34" charset="-122"/>
+                <a:cs typeface="맑은 고딕" pitchFamily="34" charset="-120"/>
+              </a:rPr>
+              <a:t>api/</a:t>
+            </a:r>
+            <a:endParaRPr lang="en-US" sz="900" dirty="0"/>
+          </a:p>
+          <a:p>
+            <a:pPr algn="ctr" indent="0" marL="0">
+              <a:buNone/>
+            </a:pPr>
+            <a:r>
+              <a:rPr lang="en-US" sz="900" b="1" dirty="0">
+                <a:solidFill>
+                  <a:srgbClr val="059669"/>
+                </a:solidFill>
+                <a:latin typeface="맑은 고딕" pitchFamily="34" charset="0"/>
+                <a:ea typeface="맑은 고딕" pitchFamily="34" charset="-122"/>
+                <a:cs typeface="맑은 고딕" pitchFamily="34" charset="-120"/>
+              </a:rPr>
+              <a:t>(라우터)</a:t>
+            </a:r>
+            <a:endParaRPr lang="en-US" sz="900" dirty="0"/>
+          </a:p>
+        </p:txBody>
+      </p:sp>
+      <p:sp>
+        <p:nvSpPr>
+          <p:cNvPr id="7" name="Shape 5"/>
+          <p:cNvSpPr/>
+          <p:nvPr/>
+        </p:nvSpPr>
+        <p:spPr>
+          <a:xfrm>
+            <a:off x="2011680" y="1828800"/>
+            <a:ext cx="1554480" cy="822960"/>
+          </a:xfrm>
+          <a:prstGeom prst="roundRect">
+            <a:avLst>
+              <a:gd name="adj" fmla="val 8889"/>
+            </a:avLst>
+          </a:prstGeom>
+          <a:solidFill>
+            <a:srgbClr val="D97706">
+              <a:alpha val="12000"/>
+            </a:srgbClr>
+          </a:solidFill>
+          <a:ln w="19050">
+            <a:solidFill>
+              <a:srgbClr val="D97706"/>
+            </a:solidFill>
+            <a:prstDash val="solid"/>
+          </a:ln>
+        </p:spPr>
+      </p:sp>
+      <p:sp>
+        <p:nvSpPr>
+          <p:cNvPr id="8" name="Text 6"/>
+          <p:cNvSpPr/>
+          <p:nvPr/>
+        </p:nvSpPr>
+        <p:spPr>
+          <a:xfrm>
+            <a:off x="2011680" y="1828800"/>
+            <a:ext cx="1554480" cy="822960"/>
+          </a:xfrm>
+          <a:prstGeom prst="rect">
+            <a:avLst/>
+          </a:prstGeom>
+          <a:noFill/>
+          <a:ln/>
+        </p:spPr>
+        <p:txBody>
+          <a:bodyPr wrap="square" rtlCol="0" anchor="ctr"/>
+          <a:lstStyle/>
+          <a:p>
+            <a:pPr algn="ctr" indent="0" marL="0">
+              <a:buNone/>
+            </a:pPr>
+            <a:r>
+              <a:rPr lang="en-US" sz="900" b="1" dirty="0">
+                <a:solidFill>
+                  <a:srgbClr val="D97706"/>
+                </a:solidFill>
+                <a:latin typeface="맑은 고딕" pitchFamily="34" charset="0"/>
+                <a:ea typeface="맑은 고딕" pitchFamily="34" charset="-122"/>
+                <a:cs typeface="맑은 고딕" pitchFamily="34" charset="-120"/>
+              </a:rPr>
+              <a:t>schedulers/</a:t>
+            </a:r>
+            <a:endParaRPr lang="en-US" sz="900" dirty="0"/>
+          </a:p>
+          <a:p>
+            <a:pPr algn="ctr" indent="0" marL="0">
+              <a:buNone/>
+            </a:pPr>
+            <a:r>
+              <a:rPr lang="en-US" sz="900" b="1" dirty="0">
+                <a:solidFill>
+                  <a:srgbClr val="D97706"/>
+                </a:solidFill>
+                <a:latin typeface="맑은 고딕" pitchFamily="34" charset="0"/>
+                <a:ea typeface="맑은 고딕" pitchFamily="34" charset="-122"/>
+                <a:cs typeface="맑은 고딕" pitchFamily="34" charset="-120"/>
+              </a:rPr>
+              <a:t>(FCFS, Priority,</a:t>
+            </a:r>
+            <a:endParaRPr lang="en-US" sz="900" dirty="0"/>
+          </a:p>
+          <a:p>
+            <a:pPr algn="ctr" indent="0" marL="0">
+              <a:buNone/>
+            </a:pPr>
+            <a:r>
+              <a:rPr lang="en-US" sz="900" b="1" dirty="0">
+                <a:solidFill>
+                  <a:srgbClr val="D97706"/>
+                </a:solidFill>
+                <a:latin typeface="맑은 고딕" pitchFamily="34" charset="0"/>
+                <a:ea typeface="맑은 고딕" pitchFamily="34" charset="-122"/>
+                <a:cs typeface="맑은 고딕" pitchFamily="34" charset="-120"/>
+              </a:rPr>
+              <a:t>MLFQ, WFQ)</a:t>
+            </a:r>
+            <a:endParaRPr lang="en-US" sz="900" dirty="0"/>
+          </a:p>
+        </p:txBody>
+      </p:sp>
+      <p:sp>
+        <p:nvSpPr>
+          <p:cNvPr id="9" name="Shape 7"/>
+          <p:cNvSpPr/>
+          <p:nvPr/>
+        </p:nvSpPr>
+        <p:spPr>
+          <a:xfrm>
+            <a:off x="3749040" y="1828800"/>
+            <a:ext cx="1554480" cy="822960"/>
+          </a:xfrm>
+          <a:prstGeom prst="roundRect">
+            <a:avLst>
+              <a:gd name="adj" fmla="val 8889"/>
+            </a:avLst>
+          </a:prstGeom>
+          <a:solidFill>
+            <a:srgbClr val="64748B">
+              <a:alpha val="12000"/>
+            </a:srgbClr>
+          </a:solidFill>
+          <a:ln w="19050">
+            <a:solidFill>
+              <a:srgbClr val="64748B"/>
+            </a:solidFill>
+            <a:prstDash val="solid"/>
+          </a:ln>
+        </p:spPr>
+      </p:sp>
+      <p:sp>
+        <p:nvSpPr>
+          <p:cNvPr id="10" name="Text 8"/>
+          <p:cNvSpPr/>
+          <p:nvPr/>
+        </p:nvSpPr>
+        <p:spPr>
+          <a:xfrm>
+            <a:off x="3749040" y="1828800"/>
+            <a:ext cx="1554480" cy="822960"/>
+          </a:xfrm>
+          <a:prstGeom prst="rect">
+            <a:avLst/>
+          </a:prstGeom>
+          <a:noFill/>
+          <a:ln/>
+        </p:spPr>
+        <p:txBody>
+          <a:bodyPr wrap="square" rtlCol="0" anchor="ctr"/>
+          <a:lstStyle/>
+          <a:p>
+            <a:pPr algn="ctr" indent="0" marL="0">
+              <a:buNone/>
+            </a:pPr>
+            <a:r>
+              <a:rPr lang="en-US" sz="900" b="1" dirty="0">
+                <a:solidFill>
+                  <a:srgbClr val="64748B"/>
+                </a:solidFill>
+                <a:latin typeface="맑은 고딕" pitchFamily="34" charset="0"/>
+                <a:ea typeface="맑은 고딕" pitchFamily="34" charset="-122"/>
+                <a:cs typeface="맑은 고딕" pitchFamily="34" charset="-120"/>
+              </a:rPr>
+              <a:t>queue/</a:t>
+            </a:r>
+            <a:endParaRPr lang="en-US" sz="900" dirty="0"/>
+          </a:p>
+          <a:p>
+            <a:pPr algn="ctr" indent="0" marL="0">
+              <a:buNone/>
+            </a:pPr>
+            <a:r>
+              <a:rPr lang="en-US" sz="900" b="1" dirty="0">
+                <a:solidFill>
+                  <a:srgbClr val="64748B"/>
+                </a:solidFill>
+                <a:latin typeface="맑은 고딕" pitchFamily="34" charset="0"/>
+                <a:ea typeface="맑은 고딕" pitchFamily="34" charset="-122"/>
+                <a:cs typeface="맑은 고딕" pitchFamily="34" charset="-120"/>
+              </a:rPr>
+              <a:t>(메모리 큐)</a:t>
+            </a:r>
+            <a:endParaRPr lang="en-US" sz="900" dirty="0"/>
+          </a:p>
+        </p:txBody>
+      </p:sp>
+      <p:sp>
+        <p:nvSpPr>
+          <p:cNvPr id="11" name="Shape 9"/>
+          <p:cNvSpPr/>
+          <p:nvPr/>
+        </p:nvSpPr>
+        <p:spPr>
+          <a:xfrm>
+            <a:off x="5486400" y="1828800"/>
+            <a:ext cx="1554480" cy="822960"/>
+          </a:xfrm>
+          <a:prstGeom prst="roundRect">
+            <a:avLst>
+              <a:gd name="adj" fmla="val 8889"/>
+            </a:avLst>
+          </a:prstGeom>
+          <a:solidFill>
+            <a:srgbClr val="64748B">
+              <a:alpha val="12000"/>
+            </a:srgbClr>
+          </a:solidFill>
+          <a:ln w="19050">
+            <a:solidFill>
+              <a:srgbClr val="64748B"/>
+            </a:solidFill>
+            <a:prstDash val="solid"/>
+          </a:ln>
+        </p:spPr>
+      </p:sp>
+      <p:sp>
+        <p:nvSpPr>
+          <p:cNvPr id="12" name="Text 10"/>
+          <p:cNvSpPr/>
+          <p:nvPr/>
+        </p:nvSpPr>
+        <p:spPr>
+          <a:xfrm>
+            <a:off x="5486400" y="1828800"/>
+            <a:ext cx="1554480" cy="822960"/>
+          </a:xfrm>
+          <a:prstGeom prst="rect">
+            <a:avLst/>
+          </a:prstGeom>
+          <a:noFill/>
+          <a:ln/>
+        </p:spPr>
+        <p:txBody>
+          <a:bodyPr wrap="square" rtlCol="0" anchor="ctr"/>
+          <a:lstStyle/>
+          <a:p>
+            <a:pPr algn="ctr" indent="0" marL="0">
+              <a:buNone/>
+            </a:pPr>
+            <a:r>
+              <a:rPr lang="en-US" sz="900" b="1" dirty="0">
+                <a:solidFill>
+                  <a:srgbClr val="64748B"/>
+                </a:solidFill>
+                <a:latin typeface="맑은 고딕" pitchFamily="34" charset="0"/>
+                <a:ea typeface="맑은 고딕" pitchFamily="34" charset="-122"/>
+                <a:cs typeface="맑은 고딕" pitchFamily="34" charset="-120"/>
+              </a:rPr>
+              <a:t>storage/</a:t>
+            </a:r>
+            <a:endParaRPr lang="en-US" sz="900" dirty="0"/>
+          </a:p>
+          <a:p>
+            <a:pPr algn="ctr" indent="0" marL="0">
+              <a:buNone/>
+            </a:pPr>
+            <a:r>
+              <a:rPr lang="en-US" sz="900" b="1" dirty="0">
+                <a:solidFill>
+                  <a:srgbClr val="64748B"/>
+                </a:solidFill>
+                <a:latin typeface="맑은 고딕" pitchFamily="34" charset="0"/>
+                <a:ea typeface="맑은 고딕" pitchFamily="34" charset="-122"/>
+                <a:cs typeface="맑은 고딕" pitchFamily="34" charset="-120"/>
+              </a:rPr>
+              <a:t>(JSON 저장)</a:t>
+            </a:r>
+            <a:endParaRPr lang="en-US" sz="900" dirty="0"/>
+          </a:p>
+        </p:txBody>
+      </p:sp>
+      <p:sp>
+        <p:nvSpPr>
+          <p:cNvPr id="13" name="Shape 11"/>
+          <p:cNvSpPr/>
+          <p:nvPr/>
+        </p:nvSpPr>
+        <p:spPr>
+          <a:xfrm>
+            <a:off x="7223760" y="1828800"/>
+            <a:ext cx="1554480" cy="822960"/>
+          </a:xfrm>
+          <a:prstGeom prst="roundRect">
+            <a:avLst>
+              <a:gd name="adj" fmla="val 8889"/>
+            </a:avLst>
+          </a:prstGeom>
+          <a:solidFill>
+            <a:srgbClr val="DC2626">
+              <a:alpha val="12000"/>
+            </a:srgbClr>
+          </a:solidFill>
+          <a:ln w="19050">
+            <a:solidFill>
+              <a:srgbClr val="DC2626"/>
+            </a:solidFill>
+            <a:prstDash val="solid"/>
+          </a:ln>
+        </p:spPr>
+      </p:sp>
+      <p:sp>
+        <p:nvSpPr>
+          <p:cNvPr id="14" name="Text 12"/>
+          <p:cNvSpPr/>
+          <p:nvPr/>
+        </p:nvSpPr>
+        <p:spPr>
+          <a:xfrm>
+            <a:off x="7223760" y="1828800"/>
+            <a:ext cx="1554480" cy="822960"/>
+          </a:xfrm>
+          <a:prstGeom prst="rect">
+            <a:avLst/>
+          </a:prstGeom>
+          <a:noFill/>
+          <a:ln/>
+        </p:spPr>
+        <p:txBody>
+          <a:bodyPr wrap="square" rtlCol="0" anchor="ctr"/>
+          <a:lstStyle/>
+          <a:p>
+            <a:pPr algn="ctr" indent="0" marL="0">
+              <a:buNone/>
+            </a:pPr>
+            <a:r>
+              <a:rPr lang="en-US" sz="900" b="1" dirty="0">
+                <a:solidFill>
+                  <a:srgbClr val="DC2626"/>
+                </a:solidFill>
+                <a:latin typeface="맑은 고딕" pitchFamily="34" charset="0"/>
+                <a:ea typeface="맑은 고딕" pitchFamily="34" charset="-122"/>
+                <a:cs typeface="맑은 고딕" pitchFamily="34" charset="-120"/>
+              </a:rPr>
+              <a:t>llm/</a:t>
+            </a:r>
+            <a:endParaRPr lang="en-US" sz="900" dirty="0"/>
+          </a:p>
+          <a:p>
+            <a:pPr algn="ctr" indent="0" marL="0">
+              <a:buNone/>
+            </a:pPr>
+            <a:r>
+              <a:rPr lang="en-US" sz="900" b="1" dirty="0">
+                <a:solidFill>
+                  <a:srgbClr val="DC2626"/>
+                </a:solidFill>
+                <a:latin typeface="맑은 고딕" pitchFamily="34" charset="0"/>
+                <a:ea typeface="맑은 고딕" pitchFamily="34" charset="-122"/>
+                <a:cs typeface="맑은 고딕" pitchFamily="34" charset="-120"/>
+              </a:rPr>
+              <a:t>(Ollama 연동)</a:t>
+            </a:r>
+            <a:endParaRPr lang="en-US" sz="900" dirty="0"/>
+          </a:p>
+        </p:txBody>
+      </p:sp>
+      <p:sp>
+        <p:nvSpPr>
+          <p:cNvPr id="15" name="Shape 13"/>
+          <p:cNvSpPr/>
+          <p:nvPr/>
+        </p:nvSpPr>
+        <p:spPr>
+          <a:xfrm>
+            <a:off x="4572000" y="1188720"/>
+            <a:ext cx="-3520440" cy="640080"/>
+          </a:xfrm>
+          <a:prstGeom prst="line">
+            <a:avLst/>
+          </a:prstGeom>
+          <a:noFill/>
+          <a:ln w="19050">
+            <a:solidFill>
+              <a:srgbClr val="CBD5E1"/>
+            </a:solidFill>
+            <a:prstDash val="solid"/>
+          </a:ln>
+        </p:spPr>
+      </p:sp>
+      <p:sp>
+        <p:nvSpPr>
+          <p:cNvPr id="16" name="Shape 14"/>
+          <p:cNvSpPr/>
+          <p:nvPr/>
+        </p:nvSpPr>
+        <p:spPr>
+          <a:xfrm>
+            <a:off x="4572000" y="1188720"/>
+            <a:ext cx="-1783080" cy="640080"/>
+          </a:xfrm>
+          <a:prstGeom prst="line">
+            <a:avLst/>
+          </a:prstGeom>
+          <a:noFill/>
+          <a:ln w="19050">
+            <a:solidFill>
+              <a:srgbClr val="CBD5E1"/>
+            </a:solidFill>
+            <a:prstDash val="solid"/>
+          </a:ln>
+        </p:spPr>
+      </p:sp>
+      <p:sp>
+        <p:nvSpPr>
+          <p:cNvPr id="17" name="Shape 15"/>
+          <p:cNvSpPr/>
+          <p:nvPr/>
+        </p:nvSpPr>
+        <p:spPr>
+          <a:xfrm>
+            <a:off x="4572000" y="1188720"/>
+            <a:ext cx="-45720" cy="640080"/>
+          </a:xfrm>
+          <a:prstGeom prst="line">
+            <a:avLst/>
+          </a:prstGeom>
+          <a:noFill/>
+          <a:ln w="19050">
+            <a:solidFill>
+              <a:srgbClr val="CBD5E1"/>
+            </a:solidFill>
+            <a:prstDash val="solid"/>
+          </a:ln>
+        </p:spPr>
+      </p:sp>
+      <p:sp>
+        <p:nvSpPr>
+          <p:cNvPr id="18" name="Shape 16"/>
+          <p:cNvSpPr/>
+          <p:nvPr/>
+        </p:nvSpPr>
+        <p:spPr>
+          <a:xfrm>
+            <a:off x="4572000" y="1188720"/>
+            <a:ext cx="1691640" cy="640080"/>
+          </a:xfrm>
+          <a:prstGeom prst="line">
+            <a:avLst/>
+          </a:prstGeom>
+          <a:noFill/>
+          <a:ln w="19050">
+            <a:solidFill>
+              <a:srgbClr val="CBD5E1"/>
+            </a:solidFill>
+            <a:prstDash val="solid"/>
+          </a:ln>
+        </p:spPr>
+      </p:sp>
+      <p:sp>
+        <p:nvSpPr>
+          <p:cNvPr id="19" name="Shape 17"/>
+          <p:cNvSpPr/>
+          <p:nvPr/>
+        </p:nvSpPr>
+        <p:spPr>
+          <a:xfrm>
+            <a:off x="4572000" y="1188720"/>
+            <a:ext cx="3429000" cy="640080"/>
+          </a:xfrm>
+          <a:prstGeom prst="line">
+            <a:avLst/>
+          </a:prstGeom>
+          <a:noFill/>
+          <a:ln w="19050">
+            <a:solidFill>
+              <a:srgbClr val="CBD5E1"/>
+            </a:solidFill>
+            <a:prstDash val="solid"/>
+          </a:ln>
+        </p:spPr>
+      </p:sp>
+      <p:sp>
+        <p:nvSpPr>
+          <p:cNvPr id="20" name="Text 18"/>
+          <p:cNvSpPr/>
+          <p:nvPr/>
+        </p:nvSpPr>
+        <p:spPr>
+          <a:xfrm>
+            <a:off x="3246120" y="2743200"/>
+            <a:ext cx="640080" cy="228600"/>
+          </a:xfrm>
+          <a:prstGeom prst="rect">
+            <a:avLst/>
+          </a:prstGeom>
+          <a:noFill/>
+          <a:ln/>
+        </p:spPr>
+        <p:txBody>
+          <a:bodyPr wrap="square" rtlCol="0" anchor="ctr"/>
+          <a:lstStyle/>
+          <a:p>
+            <a:pPr algn="ctr" indent="0" marL="0">
+              <a:buNone/>
+            </a:pPr>
+            <a:r>
+              <a:rPr lang="en-US" sz="700" dirty="0">
+                <a:solidFill>
+                  <a:srgbClr val="CBD5E1"/>
+                </a:solidFill>
+                <a:latin typeface="맑은 고딕" pitchFamily="34" charset="0"/>
+                <a:ea typeface="맑은 고딕" pitchFamily="34" charset="-122"/>
+                <a:cs typeface="맑은 고딕" pitchFamily="34" charset="-120"/>
+              </a:rPr>
+              <a:t>사용 →</a:t>
+            </a:r>
+            <a:endParaRPr lang="en-US" sz="700" dirty="0"/>
+          </a:p>
+        </p:txBody>
+      </p:sp>
+      <p:sp>
+        <p:nvSpPr>
+          <p:cNvPr id="21" name="Text 19"/>
+          <p:cNvSpPr/>
+          <p:nvPr/>
+        </p:nvSpPr>
+        <p:spPr>
+          <a:xfrm>
+            <a:off x="1508760" y="2743200"/>
+            <a:ext cx="640080" cy="228600"/>
+          </a:xfrm>
+          <a:prstGeom prst="rect">
+            <a:avLst/>
+          </a:prstGeom>
+          <a:noFill/>
+          <a:ln/>
+        </p:spPr>
+        <p:txBody>
+          <a:bodyPr wrap="square" rtlCol="0" anchor="ctr"/>
+          <a:lstStyle/>
+          <a:p>
+            <a:pPr algn="ctr" indent="0" marL="0">
+              <a:buNone/>
+            </a:pPr>
+            <a:r>
+              <a:rPr lang="en-US" sz="700" dirty="0">
+                <a:solidFill>
+                  <a:srgbClr val="CBD5E1"/>
+                </a:solidFill>
+                <a:latin typeface="맑은 고딕" pitchFamily="34" charset="0"/>
+                <a:ea typeface="맑은 고딕" pitchFamily="34" charset="-122"/>
+                <a:cs typeface="맑은 고딕" pitchFamily="34" charset="-120"/>
+              </a:rPr>
+              <a:t>호출 →</a:t>
+            </a:r>
+            <a:endParaRPr lang="en-US" sz="700" dirty="0"/>
+          </a:p>
+        </p:txBody>
+      </p:sp>
+      <p:sp>
+        <p:nvSpPr>
+          <p:cNvPr id="22" name="Shape 20"/>
+          <p:cNvSpPr/>
+          <p:nvPr/>
+        </p:nvSpPr>
+        <p:spPr>
+          <a:xfrm>
+            <a:off x="274320" y="3200400"/>
+            <a:ext cx="1554480" cy="594360"/>
+          </a:xfrm>
+          <a:prstGeom prst="roundRect">
+            <a:avLst>
+              <a:gd name="adj" fmla="val 12308"/>
+            </a:avLst>
+          </a:prstGeom>
+          <a:solidFill>
+            <a:srgbClr val="DC2626">
+              <a:alpha val="12000"/>
+            </a:srgbClr>
+          </a:solidFill>
+          <a:ln w="19050">
+            <a:solidFill>
+              <a:srgbClr val="DC2626"/>
+            </a:solidFill>
+            <a:prstDash val="solid"/>
+          </a:ln>
+        </p:spPr>
+      </p:sp>
+      <p:sp>
+        <p:nvSpPr>
+          <p:cNvPr id="23" name="Text 21"/>
+          <p:cNvSpPr/>
+          <p:nvPr/>
+        </p:nvSpPr>
+        <p:spPr>
+          <a:xfrm>
+            <a:off x="274320" y="3200400"/>
+            <a:ext cx="1554480" cy="594360"/>
+          </a:xfrm>
+          <a:prstGeom prst="rect">
+            <a:avLst/>
+          </a:prstGeom>
+          <a:noFill/>
+          <a:ln/>
+        </p:spPr>
+        <p:txBody>
+          <a:bodyPr wrap="square" rtlCol="0" anchor="ctr"/>
+          <a:lstStyle/>
+          <a:p>
+            <a:pPr algn="ctr" indent="0" marL="0">
+              <a:buNone/>
+            </a:pPr>
+            <a:r>
+              <a:rPr lang="en-US" sz="900" b="1" dirty="0">
+                <a:solidFill>
+                  <a:srgbClr val="DC2626"/>
+                </a:solidFill>
+                <a:latin typeface="맑은 고딕" pitchFamily="34" charset="0"/>
+                <a:ea typeface="맑은 고딕" pitchFamily="34" charset="-122"/>
+                <a:cs typeface="맑은 고딕" pitchFamily="34" charset="-120"/>
+              </a:rPr>
+              <a:t>rate-limiter/</a:t>
+            </a:r>
+            <a:endParaRPr lang="en-US" sz="900" dirty="0"/>
+          </a:p>
+          <a:p>
+            <a:pPr algn="ctr" indent="0" marL="0">
+              <a:buNone/>
+            </a:pPr>
+            <a:r>
+              <a:rPr lang="en-US" sz="900" b="1" dirty="0">
+                <a:solidFill>
+                  <a:srgbClr val="DC2626"/>
+                </a:solidFill>
+                <a:latin typeface="맑은 고딕" pitchFamily="34" charset="0"/>
+                <a:ea typeface="맑은 고딕" pitchFamily="34" charset="-122"/>
+                <a:cs typeface="맑은 고딕" pitchFamily="34" charset="-120"/>
+              </a:rPr>
+              <a:t>(요청 제한)</a:t>
+            </a:r>
+            <a:endParaRPr lang="en-US" sz="900" dirty="0"/>
+          </a:p>
+        </p:txBody>
+      </p:sp>
+      <p:sp>
+        <p:nvSpPr>
+          <p:cNvPr id="24" name="Shape 22"/>
+          <p:cNvSpPr/>
+          <p:nvPr/>
+        </p:nvSpPr>
+        <p:spPr>
+          <a:xfrm>
+            <a:off x="2560320" y="3931920"/>
+            <a:ext cx="4023360" cy="457200"/>
+          </a:xfrm>
+          <a:prstGeom prst="roundRect">
+            <a:avLst>
+              <a:gd name="adj" fmla="val 16000"/>
+            </a:avLst>
+          </a:prstGeom>
+          <a:solidFill>
+            <a:srgbClr val="F1F5F9"/>
+          </a:solidFill>
+          <a:ln w="12700">
+            <a:solidFill>
+              <a:srgbClr val="CBD5E1"/>
+            </a:solidFill>
+            <a:prstDash val="dash"/>
+          </a:ln>
+        </p:spPr>
+      </p:sp>
+      <p:sp>
+        <p:nvSpPr>
+          <p:cNvPr id="25" name="Text 23"/>
+          <p:cNvSpPr/>
+          <p:nvPr/>
+        </p:nvSpPr>
+        <p:spPr>
+          <a:xfrm>
+            <a:off x="2560320" y="3931920"/>
+            <a:ext cx="4023360" cy="457200"/>
+          </a:xfrm>
+          <a:prstGeom prst="rect">
+            <a:avLst/>
+          </a:prstGeom>
+          <a:noFill/>
+          <a:ln/>
+        </p:spPr>
+        <p:txBody>
+          <a:bodyPr wrap="square" rtlCol="0" anchor="ctr"/>
+          <a:lstStyle/>
+          <a:p>
+            <a:pPr algn="ctr" indent="0" marL="0">
+              <a:buNone/>
+            </a:pPr>
+            <a:r>
+              <a:rPr lang="en-US" sz="900" dirty="0">
+                <a:solidFill>
+                  <a:srgbClr val="64748B"/>
+                </a:solidFill>
+                <a:latin typeface="맑은 고딕" pitchFamily="34" charset="0"/>
+                <a:ea typeface="맑은 고딕" pitchFamily="34" charset="-122"/>
+                <a:cs typeface="맑은 고딕" pitchFamily="34" charset="-120"/>
+              </a:rPr>
+              <a:t>tests-simple/ (Jest 단위 테스트)</a:t>
+            </a:r>
+            <a:endParaRPr lang="en-US" sz="900" dirty="0"/>
+          </a:p>
+        </p:txBody>
+      </p:sp>
+      <p:sp>
+        <p:nvSpPr>
+          <p:cNvPr id="26" name="Text 24"/>
+          <p:cNvSpPr/>
+          <p:nvPr/>
+        </p:nvSpPr>
+        <p:spPr>
+          <a:xfrm>
+            <a:off x="274320" y="4572000"/>
+            <a:ext cx="3657600" cy="274320"/>
+          </a:xfrm>
+          <a:prstGeom prst="rect">
+            <a:avLst/>
+          </a:prstGeom>
+          <a:noFill/>
+          <a:ln/>
+        </p:spPr>
+        <p:txBody>
+          <a:bodyPr wrap="square" rtlCol="0" anchor="ctr"/>
+          <a:lstStyle/>
+          <a:p>
+            <a:pPr indent="0" marL="0">
+              <a:buNone/>
+            </a:pPr>
+            <a:r>
+              <a:rPr lang="en-US" sz="800" dirty="0">
+                <a:solidFill>
+                  <a:srgbClr val="64748B"/>
+                </a:solidFill>
+                <a:latin typeface="맑은 고딕" pitchFamily="34" charset="0"/>
+                <a:ea typeface="맑은 고딕" pitchFamily="34" charset="-122"/>
+                <a:cs typeface="맑은 고딕" pitchFamily="34" charset="-120"/>
+              </a:rPr>
+              <a:t>※ 화살표: 의존 관계 (호출 방향)</a:t>
+            </a:r>
+            <a:endParaRPr lang="en-US" sz="800" dirty="0"/>
           </a:p>
         </p:txBody>
       </p:sp>

</xml_diff>

<commit_message>
Add new figures and final report documents
- Created a new package.json file for the figures directory, including dependencies for Playwright, PPTXGenJS, and Sharp.
- Added multiple final report documents in various snapshots, including versions v17, v19, and v21.
</commit_message>
<xml_diff>
--- a/06-final-report/figures/final-figures.pptx
+++ b/06-final-report/figures/final-figures.pptx
@@ -6913,7 +6913,7 @@
                 <a:ea typeface="맑은 고딕" pitchFamily="34" charset="-122"/>
                 <a:cs typeface="맑은 고딕" pitchFamily="34" charset="-120"/>
               </a:rPr>
-              <a:t>2. 입력 검증</a:t>
+              <a:t>2. 요청 객체 생성</a:t>
             </a:r>
             <a:endParaRPr lang="en-US" sz="1000" dirty="0"/>
           </a:p>
@@ -10733,7 +10733,7 @@
                 <a:ea typeface="맑은 고딕" pitchFamily="34" charset="-122"/>
                 <a:cs typeface="맑은 고딕" pitchFamily="34" charset="-120"/>
               </a:rPr>
-              <a:t>5회 반복 (다중 시드) | 버스트 패턴 | 단위: 초(s)</a:t>
+              <a:t>5시드 평균 | 버스트 패턴 | 단위: 초(s)</a:t>
             </a:r>
             <a:endParaRPr lang="en-US" sz="900" dirty="0"/>
           </a:p>

</xml_diff>

<commit_message>
Update final report generation to use version 36 and adjust formatting
- Changed the input markdown file from final-report-v35.md to final-report-v36.md in generate-final.js.
- Updated page size settings for A4 formatting in the final report generation.
- Modified figure generation scripts to reflect updated experiment details, including changes in tenant representation.
- Updated binary figures in the report to reflect the latest versions.
- Regenerated final report document to include the latest changes.
</commit_message>
<xml_diff>
--- a/06-final-report/figures/final-figures.pptx
+++ b/06-final-report/figures/final-figures.pptx
@@ -9706,7 +9706,7 @@
                 <a:ea typeface="맑은 고딕" pitchFamily="34" charset="-122"/>
                 <a:cs typeface="맑은 고딕" pitchFamily="34" charset="-120"/>
               </a:rPr>
-              <a:t>500건, 4테넌트</a:t>
+              <a:t>500건, 4명 (등급별 1명)</a:t>
             </a:r>
             <a:endParaRPr lang="en-US" sz="900" dirty="0"/>
           </a:p>
@@ -10767,7 +10767,7 @@
                 <a:ea typeface="맑은 고딕" pitchFamily="34" charset="-122"/>
                 <a:cs typeface="맑은 고딕" pitchFamily="34" charset="-120"/>
               </a:rPr>
-              <a:t>기본 실험 500건 | 4개 테넌트 | 순차 도착</a:t>
+              <a:t>기본 실험 500건 | 4명 (등급별 1명) | 순차 도착</a:t>
             </a:r>
             <a:endParaRPr lang="en-US" sz="900" dirty="0"/>
           </a:p>

</xml_diff>

<commit_message>
Add final report figures and update manifest with new file details
- Added new figures: fig-6-ollama-tier.pptx, fig-7-jfi-comparison.png, and fig-7-jfi-comparison.pptx.
- Updated existing final figures presentation.
- Updated final report document with new content.
- Updated manifest.yaml with new generated timestamps, file counts, and SHA256 checksums for all files.
- Removed outdated figures and replaced them with updated versions in the manifest.
</commit_message>
<xml_diff>
--- a/06-final-report/figures/final-figures.pptx
+++ b/06-final-report/figures/final-figures.pptx
@@ -12,10 +12,9 @@
     <p:sldId id="260" r:id="rId6"/>
     <p:sldId id="261" r:id="rId7"/>
     <p:sldId id="262" r:id="rId8"/>
-    <p:sldId id="263" r:id="rId9"/>
   </p:sldIdLst>
   <p:notesMasterIdLst>
-    <p:notesMasterId r:id="rId10"/>
+    <p:notesMasterId r:id="rId9"/>
   </p:notesMasterIdLst>
   <p:sldSz cx="12192000" cy="6858000"/>
   <p:notesSz cx="6858000" cy="12192000"/>
@@ -2436,94 +2435,6 @@
 </p:notes>
 </file>
 
-<file path=ppt/notesSlides/notesSlide8.xml><?xml version="1.0" encoding="utf-8"?>
-<p:notes xmlns:a="http://schemas.openxmlformats.org/drawingml/2006/main" xmlns:r="http://schemas.openxmlformats.org/officeDocument/2006/relationships" xmlns:p="http://schemas.openxmlformats.org/presentationml/2006/main">
-  <p:cSld>
-    <p:spTree>
-      <p:nvGrpSpPr>
-        <p:cNvPr id="1" name=""/>
-        <p:cNvGrpSpPr/>
-        <p:nvPr/>
-      </p:nvGrpSpPr>
-      <p:grpSpPr>
-        <a:xfrm>
-          <a:off x="0" y="0"/>
-          <a:ext cx="0" cy="0"/>
-          <a:chOff x="0" y="0"/>
-          <a:chExt cx="0" cy="0"/>
-        </a:xfrm>
-      </p:grpSpPr>
-      <p:sp>
-        <p:nvSpPr>
-          <p:cNvPr id="2" name="Slide Image Placeholder 1"/>
-          <p:cNvSpPr>
-            <a:spLocks noGrp="1" noRot="1" noChangeAspect="1"/>
-          </p:cNvSpPr>
-          <p:nvPr>
-            <p:ph type="sldImg"/>
-          </p:nvPr>
-        </p:nvSpPr>
-        <p:spPr/>
-      </p:sp>
-      <p:sp>
-        <p:nvSpPr>
-          <p:cNvPr id="3" name="Notes Placeholder 2"/>
-          <p:cNvSpPr>
-            <a:spLocks noGrp="1"/>
-          </p:cNvSpPr>
-          <p:nvPr>
-            <p:ph type="body" idx="1"/>
-          </p:nvPr>
-        </p:nvSpPr>
-        <p:spPr/>
-        <p:txBody>
-          <a:bodyPr/>
-          <a:lstStyle/>
-          <a:p>
-            <a:r>
-              <a:rPr lang="en-US" dirty="0"/>
-              <a:t/>
-            </a:r>
-            <a:endParaRPr lang="en-US" dirty="0"/>
-          </a:p>
-        </p:txBody>
-      </p:sp>
-      <p:sp>
-        <p:nvSpPr>
-          <p:cNvPr id="4" name="Slide Number Placeholder 3"/>
-          <p:cNvSpPr>
-            <a:spLocks noGrp="1"/>
-          </p:cNvSpPr>
-          <p:nvPr>
-            <p:ph type="sldNum" sz="quarter" idx="10"/>
-          </p:nvPr>
-        </p:nvSpPr>
-        <p:spPr/>
-        <p:txBody>
-          <a:bodyPr/>
-          <a:lstStyle/>
-          <a:p>
-            <a:fld id="{F7021451-1387-4CA6-816F-3879F97B5CBC}" type="slidenum">
-              <a:rPr lang="en-US"/>
-              <a:t>8</a:t>
-            </a:fld>
-            <a:endParaRPr lang="en-US"/>
-          </a:p>
-        </p:txBody>
-      </p:sp>
-    </p:spTree>
-    <p:extLst>
-      <p:ext uri="{BB962C8B-B14F-4D97-AF65-F5344CB8AC3E}">
-        <p14:creationId xmlns:p14="http://schemas.microsoft.com/office/powerpoint/2010/main" val="1024086991"/>
-      </p:ext>
-    </p:extLst>
-  </p:cSld>
-  <p:clrMapOvr>
-    <a:masterClrMapping/>
-  </p:clrMapOvr>
-</p:notes>
-</file>
-
 <file path=ppt/slideLayouts/slideLayout1.xml><?xml version="1.0" encoding="utf-8"?>
 <p:sldLayout xmlns:a="http://schemas.openxmlformats.org/drawingml/2006/main" xmlns:r="http://schemas.openxmlformats.org/officeDocument/2006/relationships" xmlns:p="http://schemas.openxmlformats.org/presentationml/2006/main" preserve="1">
   <p:cSld name="DEFAULT">
@@ -7171,8 +7082,8 @@
         </p:nvSpPr>
         <p:spPr>
           <a:xfrm>
-            <a:off x="274320" y="45720"/>
-            <a:ext cx="8595360" cy="384048"/>
+            <a:off x="274320" y="91440"/>
+            <a:ext cx="8595360" cy="411480"/>
           </a:xfrm>
           <a:prstGeom prst="rect">
             <a:avLst/>
@@ -7196,7 +7107,7 @@
                 <a:ea typeface="맑은 고딕" pitchFamily="34" charset="-122"/>
                 <a:cs typeface="맑은 고딕" pitchFamily="34" charset="-120"/>
               </a:rPr>
-              <a:t>그림 5. 실험 환경 구성도</a:t>
+              <a:t>그림 6. 알고리즘별 평균 대기시간 비교 (ms)</a:t>
             </a:r>
             <a:endParaRPr lang="en-US" sz="1400" dirty="0"/>
           </a:p>
@@ -7204,39 +7115,14 @@
       </p:sp>
       <p:sp>
         <p:nvSpPr>
-          <p:cNvPr id="3" name="Shape 1"/>
-          <p:cNvSpPr/>
-          <p:nvPr/>
-        </p:nvSpPr>
-        <p:spPr>
-          <a:xfrm>
-            <a:off x="3154680" y="502920"/>
-            <a:ext cx="2651760" cy="502920"/>
-          </a:xfrm>
-          <a:prstGeom prst="rect">
-            <a:avLst/>
-          </a:prstGeom>
-          <a:solidFill>
-            <a:srgbClr val="333333"/>
-          </a:solidFill>
-          <a:ln w="9525">
-            <a:solidFill>
-              <a:srgbClr val="000000"/>
-            </a:solidFill>
-            <a:prstDash val="solid"/>
-          </a:ln>
-        </p:spPr>
-      </p:sp>
-      <p:sp>
-        <p:nvSpPr>
-          <p:cNvPr id="4" name="Text 2"/>
-          <p:cNvSpPr/>
-          <p:nvPr/>
-        </p:nvSpPr>
-        <p:spPr>
-          <a:xfrm>
-            <a:off x="3154680" y="502920"/>
-            <a:ext cx="2651760" cy="502920"/>
+          <p:cNvPr id="3" name="Text 1"/>
+          <p:cNvSpPr/>
+          <p:nvPr/>
+        </p:nvSpPr>
+        <p:spPr>
+          <a:xfrm>
+            <a:off x="274320" y="475488"/>
+            <a:ext cx="8595360" cy="228600"/>
           </a:xfrm>
           <a:prstGeom prst="rect">
             <a:avLst/>
@@ -7248,1235 +7134,40 @@
           <a:bodyPr wrap="square" rtlCol="0" anchor="ctr"/>
           <a:lstStyle/>
           <a:p>
-            <a:pPr algn="ctr" indent="0" marL="0">
+            <a:pPr indent="0" marL="0">
               <a:buNone/>
             </a:pPr>
             <a:r>
-              <a:rPr lang="en-US" sz="1000" b="1" dirty="0">
-                <a:solidFill>
-                  <a:srgbClr val="FFFFFF"/>
+              <a:rPr lang="en-US" sz="900" dirty="0">
+                <a:solidFill>
+                  <a:srgbClr val="333333"/>
                 </a:solidFill>
                 <a:latin typeface="맑은 고딕" pitchFamily="34" charset="0"/>
                 <a:ea typeface="맑은 고딕" pitchFamily="34" charset="-122"/>
                 <a:cs typeface="맑은 고딕" pitchFamily="34" charset="-120"/>
               </a:rPr>
-              <a:t>요청 생성 (Request Generator)</a:t>
-            </a:r>
-            <a:endParaRPr lang="en-US" sz="1000" dirty="0"/>
-          </a:p>
-        </p:txBody>
-      </p:sp>
-      <p:sp>
-        <p:nvSpPr>
-          <p:cNvPr id="5" name="Shape 3"/>
-          <p:cNvSpPr/>
-          <p:nvPr/>
-        </p:nvSpPr>
-        <p:spPr>
-          <a:xfrm>
-            <a:off x="1595628" y="1005840"/>
-            <a:ext cx="9144" cy="365760"/>
-          </a:xfrm>
-          <a:prstGeom prst="rect">
-            <a:avLst/>
-          </a:prstGeom>
-          <a:solidFill>
-            <a:srgbClr val="333333"/>
-          </a:solidFill>
-          <a:ln w="12700">
-            <a:solidFill>
-              <a:srgbClr val="333333"/>
-            </a:solidFill>
-            <a:prstDash val="solid"/>
-          </a:ln>
-        </p:spPr>
-      </p:sp>
-      <p:sp>
-        <p:nvSpPr>
-          <p:cNvPr id="6" name="Shape 4"/>
-          <p:cNvSpPr/>
-          <p:nvPr/>
-        </p:nvSpPr>
-        <p:spPr>
-          <a:xfrm rot="10800000">
-            <a:off x="1536192" y="1353312"/>
-            <a:ext cx="128016" cy="109728"/>
-          </a:xfrm>
-          <a:prstGeom prst="triangle">
-            <a:avLst/>
-          </a:prstGeom>
-          <a:solidFill>
-            <a:srgbClr val="333333"/>
-          </a:solidFill>
-          <a:ln w="6350">
-            <a:solidFill>
-              <a:srgbClr val="333333"/>
-            </a:solidFill>
-            <a:prstDash val="solid"/>
-          </a:ln>
-        </p:spPr>
-      </p:sp>
-      <p:sp>
-        <p:nvSpPr>
-          <p:cNvPr id="7" name="Shape 5"/>
-          <p:cNvSpPr/>
-          <p:nvPr/>
-        </p:nvSpPr>
-        <p:spPr>
-          <a:xfrm>
-            <a:off x="4475988" y="1005840"/>
-            <a:ext cx="9144" cy="365760"/>
-          </a:xfrm>
-          <a:prstGeom prst="rect">
-            <a:avLst/>
-          </a:prstGeom>
-          <a:solidFill>
-            <a:srgbClr val="333333"/>
-          </a:solidFill>
-          <a:ln w="12700">
-            <a:solidFill>
-              <a:srgbClr val="333333"/>
-            </a:solidFill>
-            <a:prstDash val="solid"/>
-          </a:ln>
-        </p:spPr>
-      </p:sp>
-      <p:sp>
-        <p:nvSpPr>
-          <p:cNvPr id="8" name="Shape 6"/>
-          <p:cNvSpPr/>
-          <p:nvPr/>
-        </p:nvSpPr>
-        <p:spPr>
-          <a:xfrm rot="10800000">
-            <a:off x="4416552" y="1353312"/>
-            <a:ext cx="128016" cy="109728"/>
-          </a:xfrm>
-          <a:prstGeom prst="triangle">
-            <a:avLst/>
-          </a:prstGeom>
-          <a:solidFill>
-            <a:srgbClr val="333333"/>
-          </a:solidFill>
-          <a:ln w="6350">
-            <a:solidFill>
-              <a:srgbClr val="333333"/>
-            </a:solidFill>
-            <a:prstDash val="solid"/>
-          </a:ln>
-        </p:spPr>
-      </p:sp>
-      <p:sp>
-        <p:nvSpPr>
-          <p:cNvPr id="9" name="Shape 7"/>
-          <p:cNvSpPr/>
-          <p:nvPr/>
-        </p:nvSpPr>
-        <p:spPr>
-          <a:xfrm>
-            <a:off x="7356348" y="1005840"/>
-            <a:ext cx="9144" cy="365760"/>
-          </a:xfrm>
-          <a:prstGeom prst="rect">
-            <a:avLst/>
-          </a:prstGeom>
-          <a:solidFill>
-            <a:srgbClr val="333333"/>
-          </a:solidFill>
-          <a:ln w="12700">
-            <a:solidFill>
-              <a:srgbClr val="333333"/>
-            </a:solidFill>
-            <a:prstDash val="solid"/>
-          </a:ln>
-        </p:spPr>
-      </p:sp>
-      <p:sp>
-        <p:nvSpPr>
-          <p:cNvPr id="10" name="Shape 8"/>
-          <p:cNvSpPr/>
-          <p:nvPr/>
-        </p:nvSpPr>
-        <p:spPr>
-          <a:xfrm rot="10800000">
-            <a:off x="7296912" y="1353312"/>
-            <a:ext cx="128016" cy="109728"/>
-          </a:xfrm>
-          <a:prstGeom prst="triangle">
-            <a:avLst/>
-          </a:prstGeom>
-          <a:solidFill>
-            <a:srgbClr val="333333"/>
-          </a:solidFill>
-          <a:ln w="6350">
-            <a:solidFill>
-              <a:srgbClr val="333333"/>
-            </a:solidFill>
-            <a:prstDash val="solid"/>
-          </a:ln>
-        </p:spPr>
-      </p:sp>
-      <p:sp>
-        <p:nvSpPr>
-          <p:cNvPr id="11" name="Shape 9"/>
-          <p:cNvSpPr/>
-          <p:nvPr/>
-        </p:nvSpPr>
-        <p:spPr>
-          <a:xfrm>
-            <a:off x="228600" y="1463040"/>
-            <a:ext cx="2743200" cy="868680"/>
-          </a:xfrm>
-          <a:prstGeom prst="rect">
-            <a:avLst/>
-          </a:prstGeom>
-          <a:solidFill>
-            <a:srgbClr val="FFFFFF"/>
-          </a:solidFill>
-          <a:ln w="9525">
-            <a:solidFill>
-              <a:srgbClr val="000000"/>
-            </a:solidFill>
-            <a:prstDash val="solid"/>
-          </a:ln>
-        </p:spPr>
-      </p:sp>
-      <p:sp>
-        <p:nvSpPr>
-          <p:cNvPr id="12" name="Text 10"/>
-          <p:cNvSpPr/>
-          <p:nvPr/>
-        </p:nvSpPr>
-        <p:spPr>
-          <a:xfrm>
-            <a:off x="274320" y="1508760"/>
-            <a:ext cx="2651760" cy="274320"/>
-          </a:xfrm>
-          <a:prstGeom prst="rect">
-            <a:avLst/>
-          </a:prstGeom>
-          <a:noFill/>
-          <a:ln/>
-        </p:spPr>
-        <p:txBody>
-          <a:bodyPr wrap="square" rtlCol="0" anchor="ctr"/>
-          <a:lstStyle/>
-          <a:p>
-            <a:pPr algn="ctr" indent="0" marL="0">
-              <a:buNone/>
-            </a:pPr>
-            <a:r>
-              <a:rPr lang="en-US" sz="1000" b="1" dirty="0">
-                <a:solidFill>
-                  <a:srgbClr val="000000"/>
-                </a:solidFill>
-                <a:latin typeface="맑은 고딕" pitchFamily="34" charset="0"/>
-                <a:ea typeface="맑은 고딕" pitchFamily="34" charset="-122"/>
-                <a:cs typeface="맑은 고딕" pitchFamily="34" charset="-120"/>
-              </a:rPr>
-              <a:t>기본 실험</a:t>
-            </a:r>
-            <a:endParaRPr lang="en-US" sz="1000" dirty="0"/>
-          </a:p>
-        </p:txBody>
-      </p:sp>
-      <p:sp>
-        <p:nvSpPr>
-          <p:cNvPr id="13" name="Text 11"/>
-          <p:cNvSpPr/>
-          <p:nvPr/>
-        </p:nvSpPr>
-        <p:spPr>
-          <a:xfrm>
-            <a:off x="274320" y="1783080"/>
-            <a:ext cx="2651760" cy="347472"/>
-          </a:xfrm>
-          <a:prstGeom prst="rect">
-            <a:avLst/>
-          </a:prstGeom>
-          <a:noFill/>
-          <a:ln/>
-        </p:spPr>
-        <p:txBody>
-          <a:bodyPr wrap="square" rtlCol="0" anchor="ctr"/>
-          <a:lstStyle/>
-          <a:p>
-            <a:pPr algn="ctr" indent="0" marL="0">
-              <a:buNone/>
-            </a:pPr>
-            <a:r>
-              <a:rPr lang="en-US" sz="900" dirty="0">
-                <a:solidFill>
-                  <a:srgbClr val="333333"/>
-                </a:solidFill>
-                <a:latin typeface="맑은 고딕" pitchFamily="34" charset="0"/>
-                <a:ea typeface="맑은 고딕" pitchFamily="34" charset="-122"/>
-                <a:cs typeface="맑은 고딕" pitchFamily="34" charset="-120"/>
-              </a:rPr>
-              <a:t>500건, 4명 (등급별 1명)</a:t>
+              <a:t>기본 실험 500건 | 4명 (등급별 1명) | 순차 도착</a:t>
             </a:r>
             <a:endParaRPr lang="en-US" sz="900" dirty="0"/>
           </a:p>
-          <a:p>
-            <a:pPr algn="ctr" indent="0" marL="0">
-              <a:buNone/>
-            </a:pPr>
-            <a:r>
-              <a:rPr lang="en-US" sz="900" dirty="0">
-                <a:solidFill>
-                  <a:srgbClr val="333333"/>
-                </a:solidFill>
-                <a:latin typeface="맑은 고딕" pitchFamily="34" charset="0"/>
-                <a:ea typeface="맑은 고딕" pitchFamily="34" charset="-122"/>
-                <a:cs typeface="맑은 고딕" pitchFamily="34" charset="-120"/>
-              </a:rPr>
-              <a:t>순차 도착</a:t>
-            </a:r>
-            <a:endParaRPr lang="en-US" sz="900" dirty="0"/>
-          </a:p>
-        </p:txBody>
-      </p:sp>
-      <p:sp>
-        <p:nvSpPr>
-          <p:cNvPr id="14" name="Text 12"/>
-          <p:cNvSpPr/>
-          <p:nvPr/>
-        </p:nvSpPr>
-        <p:spPr>
-          <a:xfrm>
-            <a:off x="274320" y="2121408"/>
-            <a:ext cx="2651760" cy="164592"/>
-          </a:xfrm>
-          <a:prstGeom prst="rect">
-            <a:avLst/>
-          </a:prstGeom>
-          <a:noFill/>
-          <a:ln/>
-        </p:spPr>
-        <p:txBody>
-          <a:bodyPr wrap="square" rtlCol="0" anchor="ctr"/>
-          <a:lstStyle/>
-          <a:p>
-            <a:pPr algn="ctr" indent="0" marL="0">
-              <a:buNone/>
-            </a:pPr>
-            <a:r>
-              <a:rPr lang="en-US" sz="800" dirty="0">
-                <a:solidFill>
-                  <a:srgbClr val="333333"/>
-                </a:solidFill>
-                <a:latin typeface="맑은 고딕" pitchFamily="34" charset="0"/>
-                <a:ea typeface="맑은 고딕" pitchFamily="34" charset="-122"/>
-                <a:cs typeface="맑은 고딕" pitchFamily="34" charset="-120"/>
-              </a:rPr>
-              <a:t>엔진: 시뮬레이션</a:t>
-            </a:r>
-            <a:endParaRPr lang="en-US" sz="800" dirty="0"/>
-          </a:p>
-        </p:txBody>
-      </p:sp>
-      <p:sp>
-        <p:nvSpPr>
-          <p:cNvPr id="15" name="Shape 13"/>
-          <p:cNvSpPr/>
-          <p:nvPr/>
-        </p:nvSpPr>
-        <p:spPr>
-          <a:xfrm>
-            <a:off x="3108960" y="1463040"/>
-            <a:ext cx="2743200" cy="868680"/>
-          </a:xfrm>
-          <a:prstGeom prst="rect">
-            <a:avLst/>
-          </a:prstGeom>
-          <a:solidFill>
-            <a:srgbClr val="FFFFFF"/>
-          </a:solidFill>
-          <a:ln w="9525">
-            <a:solidFill>
-              <a:srgbClr val="000000"/>
-            </a:solidFill>
-            <a:prstDash val="solid"/>
-          </a:ln>
-        </p:spPr>
-      </p:sp>
-      <p:sp>
-        <p:nvSpPr>
-          <p:cNvPr id="16" name="Text 14"/>
-          <p:cNvSpPr/>
-          <p:nvPr/>
-        </p:nvSpPr>
-        <p:spPr>
-          <a:xfrm>
-            <a:off x="3154680" y="1508760"/>
-            <a:ext cx="2651760" cy="274320"/>
-          </a:xfrm>
-          <a:prstGeom prst="rect">
-            <a:avLst/>
-          </a:prstGeom>
-          <a:noFill/>
-          <a:ln/>
-        </p:spPr>
-        <p:txBody>
-          <a:bodyPr wrap="square" rtlCol="0" anchor="ctr"/>
-          <a:lstStyle/>
-          <a:p>
-            <a:pPr algn="ctr" indent="0" marL="0">
-              <a:buNone/>
-            </a:pPr>
-            <a:r>
-              <a:rPr lang="en-US" sz="1000" b="1" dirty="0">
-                <a:solidFill>
-                  <a:srgbClr val="000000"/>
-                </a:solidFill>
-                <a:latin typeface="맑은 고딕" pitchFamily="34" charset="0"/>
-                <a:ea typeface="맑은 고딕" pitchFamily="34" charset="-122"/>
-                <a:cs typeface="맑은 고딕" pitchFamily="34" charset="-120"/>
-              </a:rPr>
-              <a:t>MLFQ 선점형 실험</a:t>
-            </a:r>
-            <a:endParaRPr lang="en-US" sz="1000" dirty="0"/>
-          </a:p>
-        </p:txBody>
-      </p:sp>
-      <p:sp>
-        <p:nvSpPr>
-          <p:cNvPr id="17" name="Text 15"/>
-          <p:cNvSpPr/>
-          <p:nvPr/>
-        </p:nvSpPr>
-        <p:spPr>
-          <a:xfrm>
-            <a:off x="3154680" y="1783080"/>
-            <a:ext cx="2651760" cy="347472"/>
-          </a:xfrm>
-          <a:prstGeom prst="rect">
-            <a:avLst/>
-          </a:prstGeom>
-          <a:noFill/>
-          <a:ln/>
-        </p:spPr>
-        <p:txBody>
-          <a:bodyPr wrap="square" rtlCol="0" anchor="ctr"/>
-          <a:lstStyle/>
-          <a:p>
-            <a:pPr algn="ctr" indent="0" marL="0">
-              <a:buNone/>
-            </a:pPr>
-            <a:r>
-              <a:rPr lang="en-US" sz="900" dirty="0">
-                <a:solidFill>
-                  <a:srgbClr val="333333"/>
-                </a:solidFill>
-                <a:latin typeface="맑은 고딕" pitchFamily="34" charset="0"/>
-                <a:ea typeface="맑은 고딕" pitchFamily="34" charset="-122"/>
-                <a:cs typeface="맑은 고딕" pitchFamily="34" charset="-120"/>
-              </a:rPr>
-              <a:t>500건 × 5시드</a:t>
-            </a:r>
-            <a:endParaRPr lang="en-US" sz="900" dirty="0"/>
-          </a:p>
-          <a:p>
-            <a:pPr algn="ctr" indent="0" marL="0">
-              <a:buNone/>
-            </a:pPr>
-            <a:r>
-              <a:rPr lang="en-US" sz="900" dirty="0">
-                <a:solidFill>
-                  <a:srgbClr val="333333"/>
-                </a:solidFill>
-                <a:latin typeface="맑은 고딕" pitchFamily="34" charset="0"/>
-                <a:ea typeface="맑은 고딕" pitchFamily="34" charset="-122"/>
-                <a:cs typeface="맑은 고딕" pitchFamily="34" charset="-120"/>
-              </a:rPr>
-              <a:t>버스트 패턴</a:t>
-            </a:r>
-            <a:endParaRPr lang="en-US" sz="900" dirty="0"/>
-          </a:p>
-        </p:txBody>
-      </p:sp>
-      <p:sp>
-        <p:nvSpPr>
-          <p:cNvPr id="18" name="Text 16"/>
-          <p:cNvSpPr/>
-          <p:nvPr/>
-        </p:nvSpPr>
-        <p:spPr>
-          <a:xfrm>
-            <a:off x="3154680" y="2121408"/>
-            <a:ext cx="2651760" cy="164592"/>
-          </a:xfrm>
-          <a:prstGeom prst="rect">
-            <a:avLst/>
-          </a:prstGeom>
-          <a:noFill/>
-          <a:ln/>
-        </p:spPr>
-        <p:txBody>
-          <a:bodyPr wrap="square" rtlCol="0" anchor="ctr"/>
-          <a:lstStyle/>
-          <a:p>
-            <a:pPr algn="ctr" indent="0" marL="0">
-              <a:buNone/>
-            </a:pPr>
-            <a:r>
-              <a:rPr lang="en-US" sz="800" dirty="0">
-                <a:solidFill>
-                  <a:srgbClr val="333333"/>
-                </a:solidFill>
-                <a:latin typeface="맑은 고딕" pitchFamily="34" charset="0"/>
-                <a:ea typeface="맑은 고딕" pitchFamily="34" charset="-122"/>
-                <a:cs typeface="맑은 고딕" pitchFamily="34" charset="-120"/>
-              </a:rPr>
-              <a:t>엔진: 시뮬레이션</a:t>
-            </a:r>
-            <a:endParaRPr lang="en-US" sz="800" dirty="0"/>
-          </a:p>
-        </p:txBody>
-      </p:sp>
-      <p:sp>
-        <p:nvSpPr>
-          <p:cNvPr id="19" name="Shape 17"/>
-          <p:cNvSpPr/>
-          <p:nvPr/>
-        </p:nvSpPr>
-        <p:spPr>
-          <a:xfrm>
-            <a:off x="5989320" y="1463040"/>
-            <a:ext cx="2743200" cy="868680"/>
-          </a:xfrm>
-          <a:prstGeom prst="rect">
-            <a:avLst/>
-          </a:prstGeom>
-          <a:solidFill>
-            <a:srgbClr val="FFFFFF"/>
-          </a:solidFill>
-          <a:ln w="9525">
-            <a:solidFill>
-              <a:srgbClr val="000000"/>
-            </a:solidFill>
-            <a:prstDash val="solid"/>
-          </a:ln>
-        </p:spPr>
-      </p:sp>
-      <p:sp>
-        <p:nvSpPr>
-          <p:cNvPr id="20" name="Text 18"/>
-          <p:cNvSpPr/>
-          <p:nvPr/>
-        </p:nvSpPr>
-        <p:spPr>
-          <a:xfrm>
-            <a:off x="6035040" y="1508760"/>
-            <a:ext cx="2651760" cy="274320"/>
-          </a:xfrm>
-          <a:prstGeom prst="rect">
-            <a:avLst/>
-          </a:prstGeom>
-          <a:noFill/>
-          <a:ln/>
-        </p:spPr>
-        <p:txBody>
-          <a:bodyPr wrap="square" rtlCol="0" anchor="ctr"/>
-          <a:lstStyle/>
-          <a:p>
-            <a:pPr algn="ctr" indent="0" marL="0">
-              <a:buNone/>
-            </a:pPr>
-            <a:r>
-              <a:rPr lang="en-US" sz="1000" b="1" dirty="0">
-                <a:solidFill>
-                  <a:srgbClr val="000000"/>
-                </a:solidFill>
-                <a:latin typeface="맑은 고딕" pitchFamily="34" charset="0"/>
-                <a:ea typeface="맑은 고딕" pitchFamily="34" charset="-122"/>
-                <a:cs typeface="맑은 고딕" pitchFamily="34" charset="-120"/>
-              </a:rPr>
-              <a:t>실서버 실험</a:t>
-            </a:r>
-            <a:endParaRPr lang="en-US" sz="1000" dirty="0"/>
-          </a:p>
-        </p:txBody>
-      </p:sp>
-      <p:sp>
-        <p:nvSpPr>
-          <p:cNvPr id="21" name="Text 19"/>
-          <p:cNvSpPr/>
-          <p:nvPr/>
-        </p:nvSpPr>
-        <p:spPr>
-          <a:xfrm>
-            <a:off x="6035040" y="1783080"/>
-            <a:ext cx="2651760" cy="347472"/>
-          </a:xfrm>
-          <a:prstGeom prst="rect">
-            <a:avLst/>
-          </a:prstGeom>
-          <a:noFill/>
-          <a:ln/>
-        </p:spPr>
-        <p:txBody>
-          <a:bodyPr wrap="square" rtlCol="0" anchor="ctr"/>
-          <a:lstStyle/>
-          <a:p>
-            <a:pPr algn="ctr" indent="0" marL="0">
-              <a:buNone/>
-            </a:pPr>
-            <a:r>
-              <a:rPr lang="en-US" sz="900" dirty="0">
-                <a:solidFill>
-                  <a:srgbClr val="333333"/>
-                </a:solidFill>
-                <a:latin typeface="맑은 고딕" pitchFamily="34" charset="0"/>
-                <a:ea typeface="맑은 고딕" pitchFamily="34" charset="-122"/>
-                <a:cs typeface="맑은 고딕" pitchFamily="34" charset="-120"/>
-              </a:rPr>
-              <a:t>20건</a:t>
-            </a:r>
-            <a:endParaRPr lang="en-US" sz="900" dirty="0"/>
-          </a:p>
-          <a:p>
-            <a:pPr algn="ctr" indent="0" marL="0">
-              <a:buNone/>
-            </a:pPr>
-            <a:r>
-              <a:rPr lang="en-US" sz="900" dirty="0">
-                <a:solidFill>
-                  <a:srgbClr val="333333"/>
-                </a:solidFill>
-                <a:latin typeface="맑은 고딕" pitchFamily="34" charset="0"/>
-                <a:ea typeface="맑은 고딕" pitchFamily="34" charset="-122"/>
-                <a:cs typeface="맑은 고딕" pitchFamily="34" charset="-120"/>
-              </a:rPr>
-              <a:t>Ollama llama3.2</a:t>
-            </a:r>
-            <a:endParaRPr lang="en-US" sz="900" dirty="0"/>
-          </a:p>
-        </p:txBody>
-      </p:sp>
-      <p:sp>
-        <p:nvSpPr>
-          <p:cNvPr id="22" name="Text 20"/>
-          <p:cNvSpPr/>
-          <p:nvPr/>
-        </p:nvSpPr>
-        <p:spPr>
-          <a:xfrm>
-            <a:off x="6035040" y="2121408"/>
-            <a:ext cx="2651760" cy="164592"/>
-          </a:xfrm>
-          <a:prstGeom prst="rect">
-            <a:avLst/>
-          </a:prstGeom>
-          <a:noFill/>
-          <a:ln/>
-        </p:spPr>
-        <p:txBody>
-          <a:bodyPr wrap="square" rtlCol="0" anchor="ctr"/>
-          <a:lstStyle/>
-          <a:p>
-            <a:pPr algn="ctr" indent="0" marL="0">
-              <a:buNone/>
-            </a:pPr>
-            <a:r>
-              <a:rPr lang="en-US" sz="800" dirty="0">
-                <a:solidFill>
-                  <a:srgbClr val="333333"/>
-                </a:solidFill>
-                <a:latin typeface="맑은 고딕" pitchFamily="34" charset="0"/>
-                <a:ea typeface="맑은 고딕" pitchFamily="34" charset="-122"/>
-                <a:cs typeface="맑은 고딕" pitchFamily="34" charset="-120"/>
-              </a:rPr>
-              <a:t>엔진: Ollama LLM</a:t>
-            </a:r>
-            <a:endParaRPr lang="en-US" sz="800" dirty="0"/>
-          </a:p>
-        </p:txBody>
-      </p:sp>
-      <p:sp>
-        <p:nvSpPr>
-          <p:cNvPr id="23" name="Shape 21"/>
-          <p:cNvSpPr/>
-          <p:nvPr/>
-        </p:nvSpPr>
-        <p:spPr>
-          <a:xfrm>
-            <a:off x="1595628" y="2331720"/>
-            <a:ext cx="9144" cy="137160"/>
-          </a:xfrm>
-          <a:prstGeom prst="rect">
-            <a:avLst/>
-          </a:prstGeom>
-          <a:solidFill>
-            <a:srgbClr val="333333"/>
-          </a:solidFill>
-          <a:ln w="12700">
-            <a:solidFill>
-              <a:srgbClr val="333333"/>
-            </a:solidFill>
-            <a:prstDash val="solid"/>
-          </a:ln>
-        </p:spPr>
-      </p:sp>
-      <p:sp>
-        <p:nvSpPr>
-          <p:cNvPr id="24" name="Shape 22"/>
-          <p:cNvSpPr/>
-          <p:nvPr/>
-        </p:nvSpPr>
-        <p:spPr>
-          <a:xfrm rot="10800000">
-            <a:off x="1536192" y="2450592"/>
-            <a:ext cx="128016" cy="109728"/>
-          </a:xfrm>
-          <a:prstGeom prst="triangle">
-            <a:avLst/>
-          </a:prstGeom>
-          <a:solidFill>
-            <a:srgbClr val="333333"/>
-          </a:solidFill>
-          <a:ln w="6350">
-            <a:solidFill>
-              <a:srgbClr val="333333"/>
-            </a:solidFill>
-            <a:prstDash val="solid"/>
-          </a:ln>
-        </p:spPr>
-      </p:sp>
-      <p:sp>
-        <p:nvSpPr>
-          <p:cNvPr id="25" name="Shape 23"/>
-          <p:cNvSpPr/>
-          <p:nvPr/>
-        </p:nvSpPr>
-        <p:spPr>
-          <a:xfrm>
-            <a:off x="4475988" y="2331720"/>
-            <a:ext cx="9144" cy="137160"/>
-          </a:xfrm>
-          <a:prstGeom prst="rect">
-            <a:avLst/>
-          </a:prstGeom>
-          <a:solidFill>
-            <a:srgbClr val="333333"/>
-          </a:solidFill>
-          <a:ln w="12700">
-            <a:solidFill>
-              <a:srgbClr val="333333"/>
-            </a:solidFill>
-            <a:prstDash val="solid"/>
-          </a:ln>
-        </p:spPr>
-      </p:sp>
-      <p:sp>
-        <p:nvSpPr>
-          <p:cNvPr id="26" name="Shape 24"/>
-          <p:cNvSpPr/>
-          <p:nvPr/>
-        </p:nvSpPr>
-        <p:spPr>
-          <a:xfrm rot="10800000">
-            <a:off x="4416552" y="2450592"/>
-            <a:ext cx="128016" cy="109728"/>
-          </a:xfrm>
-          <a:prstGeom prst="triangle">
-            <a:avLst/>
-          </a:prstGeom>
-          <a:solidFill>
-            <a:srgbClr val="333333"/>
-          </a:solidFill>
-          <a:ln w="6350">
-            <a:solidFill>
-              <a:srgbClr val="333333"/>
-            </a:solidFill>
-            <a:prstDash val="solid"/>
-          </a:ln>
-        </p:spPr>
-      </p:sp>
-      <p:sp>
-        <p:nvSpPr>
-          <p:cNvPr id="27" name="Shape 25"/>
-          <p:cNvSpPr/>
-          <p:nvPr/>
-        </p:nvSpPr>
-        <p:spPr>
-          <a:xfrm>
-            <a:off x="7356348" y="2331720"/>
-            <a:ext cx="9144" cy="137160"/>
-          </a:xfrm>
-          <a:prstGeom prst="rect">
-            <a:avLst/>
-          </a:prstGeom>
-          <a:solidFill>
-            <a:srgbClr val="333333"/>
-          </a:solidFill>
-          <a:ln w="12700">
-            <a:solidFill>
-              <a:srgbClr val="333333"/>
-            </a:solidFill>
-            <a:prstDash val="solid"/>
-          </a:ln>
-        </p:spPr>
-      </p:sp>
-      <p:sp>
-        <p:nvSpPr>
-          <p:cNvPr id="28" name="Shape 26"/>
-          <p:cNvSpPr/>
-          <p:nvPr/>
-        </p:nvSpPr>
-        <p:spPr>
-          <a:xfrm rot="10800000">
-            <a:off x="7296912" y="2450592"/>
-            <a:ext cx="128016" cy="109728"/>
-          </a:xfrm>
-          <a:prstGeom prst="triangle">
-            <a:avLst/>
-          </a:prstGeom>
-          <a:solidFill>
-            <a:srgbClr val="333333"/>
-          </a:solidFill>
-          <a:ln w="6350">
-            <a:solidFill>
-              <a:srgbClr val="333333"/>
-            </a:solidFill>
-            <a:prstDash val="solid"/>
-          </a:ln>
-        </p:spPr>
-      </p:sp>
-      <p:sp>
-        <p:nvSpPr>
-          <p:cNvPr id="29" name="Shape 27"/>
-          <p:cNvSpPr/>
-          <p:nvPr/>
-        </p:nvSpPr>
-        <p:spPr>
-          <a:xfrm>
-            <a:off x="228600" y="2560320"/>
-            <a:ext cx="8686800" cy="658368"/>
-          </a:xfrm>
-          <a:prstGeom prst="rect">
-            <a:avLst/>
-          </a:prstGeom>
-          <a:solidFill>
-            <a:srgbClr val="F5F5F5"/>
-          </a:solidFill>
-          <a:ln w="9525">
-            <a:solidFill>
-              <a:srgbClr val="000000"/>
-            </a:solidFill>
-            <a:prstDash val="solid"/>
-          </a:ln>
-        </p:spPr>
-      </p:sp>
-      <p:sp>
-        <p:nvSpPr>
-          <p:cNvPr id="30" name="Text 28"/>
-          <p:cNvSpPr/>
-          <p:nvPr/>
-        </p:nvSpPr>
-        <p:spPr>
-          <a:xfrm>
-            <a:off x="365760" y="2596896"/>
-            <a:ext cx="3200400" cy="256032"/>
-          </a:xfrm>
-          <a:prstGeom prst="rect">
-            <a:avLst/>
-          </a:prstGeom>
-          <a:noFill/>
-          <a:ln/>
-        </p:spPr>
-        <p:txBody>
-          <a:bodyPr wrap="square" rtlCol="0" anchor="ctr"/>
-          <a:lstStyle/>
-          <a:p>
-            <a:pPr indent="0" marL="0">
-              <a:buNone/>
-            </a:pPr>
-            <a:r>
-              <a:rPr lang="en-US" sz="1000" b="1" dirty="0">
-                <a:solidFill>
-                  <a:srgbClr val="000000"/>
-                </a:solidFill>
-                <a:latin typeface="맑은 고딕" pitchFamily="34" charset="0"/>
-                <a:ea typeface="맑은 고딕" pitchFamily="34" charset="-122"/>
-                <a:cs typeface="맑은 고딕" pitchFamily="34" charset="-120"/>
-              </a:rPr>
-              <a:t>스케줄러 계층 (Scheduler Layer)</a:t>
-            </a:r>
-            <a:endParaRPr lang="en-US" sz="1000" dirty="0"/>
-          </a:p>
-        </p:txBody>
-      </p:sp>
-      <p:sp>
-        <p:nvSpPr>
-          <p:cNvPr id="31" name="Shape 29"/>
-          <p:cNvSpPr/>
-          <p:nvPr/>
-        </p:nvSpPr>
-        <p:spPr>
-          <a:xfrm>
-            <a:off x="1645920" y="2862072"/>
-            <a:ext cx="1371600" cy="256032"/>
-          </a:xfrm>
-          <a:prstGeom prst="rect">
-            <a:avLst/>
-          </a:prstGeom>
-          <a:solidFill>
-            <a:srgbClr val="FFFFFF"/>
-          </a:solidFill>
-          <a:ln w="6350">
-            <a:solidFill>
-              <a:srgbClr val="000000"/>
-            </a:solidFill>
-            <a:prstDash val="solid"/>
-          </a:ln>
-        </p:spPr>
-      </p:sp>
-      <p:sp>
-        <p:nvSpPr>
-          <p:cNvPr id="32" name="Text 30"/>
-          <p:cNvSpPr/>
-          <p:nvPr/>
-        </p:nvSpPr>
-        <p:spPr>
-          <a:xfrm>
-            <a:off x="1645920" y="2862072"/>
-            <a:ext cx="1371600" cy="256032"/>
-          </a:xfrm>
-          <a:prstGeom prst="rect">
-            <a:avLst/>
-          </a:prstGeom>
-          <a:noFill/>
-          <a:ln/>
-        </p:spPr>
-        <p:txBody>
-          <a:bodyPr wrap="square" rtlCol="0" anchor="ctr"/>
-          <a:lstStyle/>
-          <a:p>
-            <a:pPr algn="ctr" indent="0" marL="0">
-              <a:buNone/>
-            </a:pPr>
-            <a:r>
-              <a:rPr lang="en-US" sz="900" dirty="0">
-                <a:solidFill>
-                  <a:srgbClr val="000000"/>
-                </a:solidFill>
-                <a:latin typeface="맑은 고딕" pitchFamily="34" charset="0"/>
-                <a:ea typeface="맑은 고딕" pitchFamily="34" charset="-122"/>
-                <a:cs typeface="맑은 고딕" pitchFamily="34" charset="-120"/>
-              </a:rPr>
-              <a:t>FCFS</a:t>
-            </a:r>
-            <a:endParaRPr lang="en-US" sz="900" dirty="0"/>
-          </a:p>
-        </p:txBody>
-      </p:sp>
-      <p:sp>
-        <p:nvSpPr>
-          <p:cNvPr id="33" name="Shape 31"/>
-          <p:cNvSpPr/>
-          <p:nvPr/>
-        </p:nvSpPr>
-        <p:spPr>
-          <a:xfrm>
-            <a:off x="3291840" y="2862072"/>
-            <a:ext cx="1371600" cy="256032"/>
-          </a:xfrm>
-          <a:prstGeom prst="rect">
-            <a:avLst/>
-          </a:prstGeom>
-          <a:solidFill>
-            <a:srgbClr val="FFFFFF"/>
-          </a:solidFill>
-          <a:ln w="6350">
-            <a:solidFill>
-              <a:srgbClr val="000000"/>
-            </a:solidFill>
-            <a:prstDash val="solid"/>
-          </a:ln>
-        </p:spPr>
-      </p:sp>
-      <p:sp>
-        <p:nvSpPr>
-          <p:cNvPr id="34" name="Text 32"/>
-          <p:cNvSpPr/>
-          <p:nvPr/>
-        </p:nvSpPr>
-        <p:spPr>
-          <a:xfrm>
-            <a:off x="3291840" y="2862072"/>
-            <a:ext cx="1371600" cy="256032"/>
-          </a:xfrm>
-          <a:prstGeom prst="rect">
-            <a:avLst/>
-          </a:prstGeom>
-          <a:noFill/>
-          <a:ln/>
-        </p:spPr>
-        <p:txBody>
-          <a:bodyPr wrap="square" rtlCol="0" anchor="ctr"/>
-          <a:lstStyle/>
-          <a:p>
-            <a:pPr algn="ctr" indent="0" marL="0">
-              <a:buNone/>
-            </a:pPr>
-            <a:r>
-              <a:rPr lang="en-US" sz="900" dirty="0">
-                <a:solidFill>
-                  <a:srgbClr val="000000"/>
-                </a:solidFill>
-                <a:latin typeface="맑은 고딕" pitchFamily="34" charset="0"/>
-                <a:ea typeface="맑은 고딕" pitchFamily="34" charset="-122"/>
-                <a:cs typeface="맑은 고딕" pitchFamily="34" charset="-120"/>
-              </a:rPr>
-              <a:t>Priority</a:t>
-            </a:r>
-            <a:endParaRPr lang="en-US" sz="900" dirty="0"/>
-          </a:p>
-        </p:txBody>
-      </p:sp>
-      <p:sp>
-        <p:nvSpPr>
-          <p:cNvPr id="35" name="Shape 33"/>
-          <p:cNvSpPr/>
-          <p:nvPr/>
-        </p:nvSpPr>
-        <p:spPr>
-          <a:xfrm>
-            <a:off x="4937760" y="2862072"/>
-            <a:ext cx="1371600" cy="256032"/>
-          </a:xfrm>
-          <a:prstGeom prst="rect">
-            <a:avLst/>
-          </a:prstGeom>
-          <a:solidFill>
-            <a:srgbClr val="FFFFFF"/>
-          </a:solidFill>
-          <a:ln w="6350">
-            <a:solidFill>
-              <a:srgbClr val="000000"/>
-            </a:solidFill>
-            <a:prstDash val="solid"/>
-          </a:ln>
-        </p:spPr>
-      </p:sp>
-      <p:sp>
-        <p:nvSpPr>
-          <p:cNvPr id="36" name="Text 34"/>
-          <p:cNvSpPr/>
-          <p:nvPr/>
-        </p:nvSpPr>
-        <p:spPr>
-          <a:xfrm>
-            <a:off x="4937760" y="2862072"/>
-            <a:ext cx="1371600" cy="256032"/>
-          </a:xfrm>
-          <a:prstGeom prst="rect">
-            <a:avLst/>
-          </a:prstGeom>
-          <a:noFill/>
-          <a:ln/>
-        </p:spPr>
-        <p:txBody>
-          <a:bodyPr wrap="square" rtlCol="0" anchor="ctr"/>
-          <a:lstStyle/>
-          <a:p>
-            <a:pPr algn="ctr" indent="0" marL="0">
-              <a:buNone/>
-            </a:pPr>
-            <a:r>
-              <a:rPr lang="en-US" sz="900" dirty="0">
-                <a:solidFill>
-                  <a:srgbClr val="000000"/>
-                </a:solidFill>
-                <a:latin typeface="맑은 고딕" pitchFamily="34" charset="0"/>
-                <a:ea typeface="맑은 고딕" pitchFamily="34" charset="-122"/>
-                <a:cs typeface="맑은 고딕" pitchFamily="34" charset="-120"/>
-              </a:rPr>
-              <a:t>MLFQ</a:t>
-            </a:r>
-            <a:endParaRPr lang="en-US" sz="900" dirty="0"/>
-          </a:p>
-        </p:txBody>
-      </p:sp>
-      <p:sp>
-        <p:nvSpPr>
-          <p:cNvPr id="37" name="Shape 35"/>
-          <p:cNvSpPr/>
-          <p:nvPr/>
-        </p:nvSpPr>
-        <p:spPr>
-          <a:xfrm>
-            <a:off x="6583680" y="2862072"/>
-            <a:ext cx="1371600" cy="256032"/>
-          </a:xfrm>
-          <a:prstGeom prst="rect">
-            <a:avLst/>
-          </a:prstGeom>
-          <a:solidFill>
-            <a:srgbClr val="FFFFFF"/>
-          </a:solidFill>
-          <a:ln w="6350">
-            <a:solidFill>
-              <a:srgbClr val="000000"/>
-            </a:solidFill>
-            <a:prstDash val="solid"/>
-          </a:ln>
-        </p:spPr>
-      </p:sp>
-      <p:sp>
-        <p:nvSpPr>
-          <p:cNvPr id="38" name="Text 36"/>
-          <p:cNvSpPr/>
-          <p:nvPr/>
-        </p:nvSpPr>
-        <p:spPr>
-          <a:xfrm>
-            <a:off x="6583680" y="2862072"/>
-            <a:ext cx="1371600" cy="256032"/>
-          </a:xfrm>
-          <a:prstGeom prst="rect">
-            <a:avLst/>
-          </a:prstGeom>
-          <a:noFill/>
-          <a:ln/>
-        </p:spPr>
-        <p:txBody>
-          <a:bodyPr wrap="square" rtlCol="0" anchor="ctr"/>
-          <a:lstStyle/>
-          <a:p>
-            <a:pPr algn="ctr" indent="0" marL="0">
-              <a:buNone/>
-            </a:pPr>
-            <a:r>
-              <a:rPr lang="en-US" sz="900" dirty="0">
-                <a:solidFill>
-                  <a:srgbClr val="000000"/>
-                </a:solidFill>
-                <a:latin typeface="맑은 고딕" pitchFamily="34" charset="0"/>
-                <a:ea typeface="맑은 고딕" pitchFamily="34" charset="-122"/>
-                <a:cs typeface="맑은 고딕" pitchFamily="34" charset="-120"/>
-              </a:rPr>
-              <a:t>WFQ</a:t>
-            </a:r>
-            <a:endParaRPr lang="en-US" sz="900" dirty="0"/>
-          </a:p>
-        </p:txBody>
-      </p:sp>
-      <p:sp>
-        <p:nvSpPr>
-          <p:cNvPr id="39" name="Shape 37"/>
-          <p:cNvSpPr/>
-          <p:nvPr/>
-        </p:nvSpPr>
-        <p:spPr>
-          <a:xfrm>
-            <a:off x="4430268" y="3218688"/>
-            <a:ext cx="9144" cy="274320"/>
-          </a:xfrm>
-          <a:prstGeom prst="rect">
-            <a:avLst/>
-          </a:prstGeom>
-          <a:solidFill>
-            <a:srgbClr val="333333"/>
-          </a:solidFill>
-          <a:ln w="12700">
-            <a:solidFill>
-              <a:srgbClr val="333333"/>
-            </a:solidFill>
-            <a:prstDash val="solid"/>
-          </a:ln>
-        </p:spPr>
-      </p:sp>
-      <p:sp>
-        <p:nvSpPr>
-          <p:cNvPr id="40" name="Shape 38"/>
-          <p:cNvSpPr/>
-          <p:nvPr/>
-        </p:nvSpPr>
-        <p:spPr>
-          <a:xfrm rot="10800000">
-            <a:off x="4370832" y="3419856"/>
-            <a:ext cx="128016" cy="109728"/>
-          </a:xfrm>
-          <a:prstGeom prst="triangle">
-            <a:avLst/>
-          </a:prstGeom>
-          <a:solidFill>
-            <a:srgbClr val="333333"/>
-          </a:solidFill>
-          <a:ln w="6350">
-            <a:solidFill>
-              <a:srgbClr val="333333"/>
-            </a:solidFill>
-            <a:prstDash val="solid"/>
-          </a:ln>
-        </p:spPr>
-      </p:sp>
-      <p:sp>
-        <p:nvSpPr>
-          <p:cNvPr id="41" name="Shape 39"/>
-          <p:cNvSpPr/>
-          <p:nvPr/>
-        </p:nvSpPr>
-        <p:spPr>
-          <a:xfrm>
-            <a:off x="228600" y="3520440"/>
-            <a:ext cx="8686800" cy="566928"/>
-          </a:xfrm>
-          <a:prstGeom prst="rect">
-            <a:avLst/>
-          </a:prstGeom>
-          <a:solidFill>
-            <a:srgbClr val="F5F5F5"/>
-          </a:solidFill>
-          <a:ln w="9525">
-            <a:solidFill>
-              <a:srgbClr val="000000"/>
-            </a:solidFill>
-            <a:prstDash val="solid"/>
-          </a:ln>
-        </p:spPr>
-      </p:sp>
-      <p:sp>
-        <p:nvSpPr>
-          <p:cNvPr id="42" name="Text 40"/>
-          <p:cNvSpPr/>
-          <p:nvPr/>
-        </p:nvSpPr>
-        <p:spPr>
-          <a:xfrm>
-            <a:off x="365760" y="3520440"/>
-            <a:ext cx="8412480" cy="566928"/>
-          </a:xfrm>
-          <a:prstGeom prst="rect">
-            <a:avLst/>
-          </a:prstGeom>
-          <a:noFill/>
-          <a:ln/>
-        </p:spPr>
-        <p:txBody>
-          <a:bodyPr wrap="square" rtlCol="0" anchor="ctr"/>
-          <a:lstStyle/>
-          <a:p>
-            <a:pPr algn="ctr" indent="0" marL="0">
-              <a:buNone/>
-            </a:pPr>
-            <a:r>
-              <a:rPr lang="en-US" sz="1000" dirty="0">
-                <a:solidFill>
-                  <a:srgbClr val="000000"/>
-                </a:solidFill>
-                <a:latin typeface="맑은 고딕" pitchFamily="34" charset="0"/>
-                <a:ea typeface="맑은 고딕" pitchFamily="34" charset="-122"/>
-                <a:cs typeface="맑은 고딕" pitchFamily="34" charset="-120"/>
-              </a:rPr>
-              <a:t>결과 측정: 평균 대기시간 · JFI · 요청 유형별 응답시간 · JSON 로그 기록</a:t>
-            </a:r>
-            <a:endParaRPr lang="en-US" sz="1000" dirty="0"/>
-          </a:p>
-        </p:txBody>
-      </p:sp>
+        </p:txBody>
+      </p:sp>
+      <p:graphicFrame>
+        <p:nvGraphicFramePr>
+          <p:cNvPr id="4" name="Chart 0" descr=""/>
+          <p:cNvGraphicFramePr/>
+          <p:nvPr/>
+        </p:nvGraphicFramePr>
+        <p:xfrm>
+          <a:off x="457200" y="777240"/>
+          <a:ext cx="8229600" cy="3977640"/>
+        </p:xfrm>
+        <a:graphic xmlns:a="http://schemas.openxmlformats.org/drawingml/2006/main">
+          <a:graphicData uri="http://schemas.openxmlformats.org/drawingml/2006/chart">
+            <c:chart xmlns:c="http://schemas.openxmlformats.org/drawingml/2006/chart" r:id="rId1"/>
+          </a:graphicData>
+        </a:graphic>
+      </p:graphicFrame>
     </p:spTree>
   </p:cSld>
   <p:clrMapOvr>
@@ -8535,7 +7226,7 @@
                 <a:ea typeface="맑은 고딕" pitchFamily="34" charset="-122"/>
                 <a:cs typeface="맑은 고딕" pitchFamily="34" charset="-120"/>
               </a:rPr>
-              <a:t>그림 6. 알고리즘별 평균 대기시간 비교 (ms)</a:t>
+              <a:t>그림 7. MLFQ 선점형 vs FCFS — 요청 유형별 응답시간</a:t>
             </a:r>
             <a:endParaRPr lang="en-US" sz="1400" dirty="0"/>
           </a:p>
@@ -8574,7 +7265,7 @@
                 <a:ea typeface="맑은 고딕" pitchFamily="34" charset="-122"/>
                 <a:cs typeface="맑은 고딕" pitchFamily="34" charset="-120"/>
               </a:rPr>
-              <a:t>기본 실험 500건 | 4명 (등급별 1명) | 순차 도착</a:t>
+              <a:t>5시드 평균 | 버스트 패턴 | 단위: 초(s)</a:t>
             </a:r>
             <a:endParaRPr lang="en-US" sz="900" dirty="0"/>
           </a:p>
@@ -8588,7 +7279,7 @@
         </p:nvGraphicFramePr>
         <p:xfrm>
           <a:off x="457200" y="777240"/>
-          <a:ext cx="8229600" cy="3977640"/>
+          <a:ext cx="7772400" cy="3977640"/>
         </p:xfrm>
         <a:graphic xmlns:a="http://schemas.openxmlformats.org/drawingml/2006/main">
           <a:graphicData uri="http://schemas.openxmlformats.org/drawingml/2006/chart">
@@ -8654,125 +7345,6 @@
                 <a:ea typeface="맑은 고딕" pitchFamily="34" charset="-122"/>
                 <a:cs typeface="맑은 고딕" pitchFamily="34" charset="-120"/>
               </a:rPr>
-              <a:t>그림 7. MLFQ 선점형 vs FCFS — 요청 유형별 응답시간</a:t>
-            </a:r>
-            <a:endParaRPr lang="en-US" sz="1400" dirty="0"/>
-          </a:p>
-        </p:txBody>
-      </p:sp>
-      <p:sp>
-        <p:nvSpPr>
-          <p:cNvPr id="3" name="Text 1"/>
-          <p:cNvSpPr/>
-          <p:nvPr/>
-        </p:nvSpPr>
-        <p:spPr>
-          <a:xfrm>
-            <a:off x="274320" y="475488"/>
-            <a:ext cx="8595360" cy="228600"/>
-          </a:xfrm>
-          <a:prstGeom prst="rect">
-            <a:avLst/>
-          </a:prstGeom>
-          <a:noFill/>
-          <a:ln/>
-        </p:spPr>
-        <p:txBody>
-          <a:bodyPr wrap="square" rtlCol="0" anchor="ctr"/>
-          <a:lstStyle/>
-          <a:p>
-            <a:pPr indent="0" marL="0">
-              <a:buNone/>
-            </a:pPr>
-            <a:r>
-              <a:rPr lang="en-US" sz="900" dirty="0">
-                <a:solidFill>
-                  <a:srgbClr val="333333"/>
-                </a:solidFill>
-                <a:latin typeface="맑은 고딕" pitchFamily="34" charset="0"/>
-                <a:ea typeface="맑은 고딕" pitchFamily="34" charset="-122"/>
-                <a:cs typeface="맑은 고딕" pitchFamily="34" charset="-120"/>
-              </a:rPr>
-              <a:t>5시드 평균 | 버스트 패턴 | 단위: 초(s)</a:t>
-            </a:r>
-            <a:endParaRPr lang="en-US" sz="900" dirty="0"/>
-          </a:p>
-        </p:txBody>
-      </p:sp>
-      <p:graphicFrame>
-        <p:nvGraphicFramePr>
-          <p:cNvPr id="4" name="Chart 0" descr=""/>
-          <p:cNvGraphicFramePr/>
-          <p:nvPr/>
-        </p:nvGraphicFramePr>
-        <p:xfrm>
-          <a:off x="457200" y="777240"/>
-          <a:ext cx="7772400" cy="3977640"/>
-        </p:xfrm>
-        <a:graphic xmlns:a="http://schemas.openxmlformats.org/drawingml/2006/main">
-          <a:graphicData uri="http://schemas.openxmlformats.org/drawingml/2006/chart">
-            <c:chart xmlns:c="http://schemas.openxmlformats.org/drawingml/2006/chart" r:id="rId1"/>
-          </a:graphicData>
-        </a:graphic>
-      </p:graphicFrame>
-    </p:spTree>
-  </p:cSld>
-  <p:clrMapOvr>
-    <a:masterClrMapping/>
-  </p:clrMapOvr>
-</p:sld>
-</file>
-
-<file path=ppt/slides/slide7.xml><?xml version="1.0" encoding="utf-8"?>
-<p:sld xmlns:a="http://schemas.openxmlformats.org/drawingml/2006/main" xmlns:r="http://schemas.openxmlformats.org/officeDocument/2006/relationships" xmlns:p="http://schemas.openxmlformats.org/presentationml/2006/main">
-  <p:cSld name="Slide 7">
-    <p:spTree>
-      <p:nvGrpSpPr>
-        <p:cNvPr id="1" name=""/>
-        <p:cNvGrpSpPr/>
-        <p:nvPr/>
-      </p:nvGrpSpPr>
-      <p:grpSpPr>
-        <a:xfrm>
-          <a:off x="0" y="0"/>
-          <a:ext cx="0" cy="0"/>
-          <a:chOff x="0" y="0"/>
-          <a:chExt cx="0" cy="0"/>
-        </a:xfrm>
-      </p:grpSpPr>
-      <p:sp>
-        <p:nvSpPr>
-          <p:cNvPr id="2" name="Text 0"/>
-          <p:cNvSpPr/>
-          <p:nvPr/>
-        </p:nvSpPr>
-        <p:spPr>
-          <a:xfrm>
-            <a:off x="274320" y="91440"/>
-            <a:ext cx="8595360" cy="411480"/>
-          </a:xfrm>
-          <a:prstGeom prst="rect">
-            <a:avLst/>
-          </a:prstGeom>
-          <a:noFill/>
-          <a:ln/>
-        </p:spPr>
-        <p:txBody>
-          <a:bodyPr wrap="square" rtlCol="0" anchor="ctr"/>
-          <a:lstStyle/>
-          <a:p>
-            <a:pPr algn="ctr" indent="0" marL="0">
-              <a:buNone/>
-            </a:pPr>
-            <a:r>
-              <a:rPr lang="en-US" sz="1400" b="1" dirty="0">
-                <a:solidFill>
-                  <a:srgbClr val="000000"/>
-                </a:solidFill>
-                <a:latin typeface="맑은 고딕" pitchFamily="34" charset="0"/>
-                <a:ea typeface="맑은 고딕" pitchFamily="34" charset="-122"/>
-                <a:cs typeface="맑은 고딕" pitchFamily="34" charset="-120"/>
-              </a:rPr>
               <a:t>그림 8. 실서버 구독 등급별 평균 대기시간 (ms)</a:t>
             </a:r>
             <a:endParaRPr lang="en-US" sz="1400" dirty="0"/>
@@ -8842,9 +7414,9 @@
 </p:sld>
 </file>
 
-<file path=ppt/slides/slide8.xml><?xml version="1.0" encoding="utf-8"?>
+<file path=ppt/slides/slide7.xml><?xml version="1.0" encoding="utf-8"?>
 <p:sld xmlns:a="http://schemas.openxmlformats.org/drawingml/2006/main" xmlns:r="http://schemas.openxmlformats.org/officeDocument/2006/relationships" xmlns:p="http://schemas.openxmlformats.org/presentationml/2006/main">
-  <p:cSld name="Slide 8">
+  <p:cSld name="Slide 7">
     <p:spTree>
       <p:nvGrpSpPr>
         <p:cNvPr id="1" name=""/>

</xml_diff>

<commit_message>
Remove obsolete figures and update final report files; adjust manifest for new file sizes and timestamps.
</commit_message>
<xml_diff>
--- a/06-final-report/figures/final-figures.pptx
+++ b/06-final-report/figures/final-figures.pptx
@@ -10,11 +10,9 @@
     <p:sldId id="258" r:id="rId4"/>
     <p:sldId id="259" r:id="rId5"/>
     <p:sldId id="260" r:id="rId6"/>
-    <p:sldId id="261" r:id="rId7"/>
-    <p:sldId id="262" r:id="rId8"/>
   </p:sldIdLst>
   <p:notesMasterIdLst>
-    <p:notesMasterId r:id="rId9"/>
+    <p:notesMasterId r:id="rId7"/>
   </p:notesMasterIdLst>
   <p:sldSz cx="12192000" cy="6858000"/>
   <p:notesSz cx="6858000" cy="12192000"/>
@@ -113,297 +111,7 @@
 </p:presentation>
 </file>
 
-<file path=ppt/charts/chart5.xml><?xml version="1.0" encoding="utf-8"?>
-<c:chartSpace xmlns:c="http://schemas.openxmlformats.org/drawingml/2006/chart" xmlns:a="http://schemas.openxmlformats.org/drawingml/2006/main" xmlns:r="http://schemas.openxmlformats.org/officeDocument/2006/relationships">
-  <c:date1904 val="0"/>
-  <c:roundedCorners val="1"/>
-  <c:chart>
-    <c:autoTitleDeleted val="1"/>
-    <c:plotArea>
-      <c:layout/>
-      <c:barChart>
-        <c:barDir val="col"/>
-        <c:grouping val="clustered"/>
-        <c:varyColors val="0"/>
-        <c:ser>
-          <c:idx val="0"/>
-          <c:order val="0"/>
-          <c:tx>
-            <c:strRef>
-              <c:f>Sheet1!$B$1</c:f>
-              <c:strCache>
-                <c:ptCount val="1"/>
-                <c:pt idx="0">
-                  <c:v>평균 대기시간 (ms)</c:v>
-                </c:pt>
-              </c:strCache>
-            </c:strRef>
-          </c:tx>
-          <c:spPr>
-            <a:solidFill>
-              <a:srgbClr val="333333"/>
-            </a:solidFill>
-            <a:effectLst/>
-          </c:spPr>
-          <c:invertIfNegative val="0"/>
-          <c:dLbls>
-            <c:numFmt formatCode="#,##0" sourceLinked="0"/>
-            <c:txPr>
-              <a:bodyPr/>
-              <a:lstStyle/>
-              <a:p>
-                <a:pPr>
-                  <a:defRPr b="0" i="0" strike="noStrike" sz="1000" u="none">
-                    <a:solidFill>
-                      <a:srgbClr val="000000"/>
-                    </a:solidFill>
-                    <a:latin typeface="Arial"/>
-                  </a:defRPr>
-                </a:pPr>
-              </a:p>
-            </c:txPr>
-            <c:showLegendKey val="0"/>
-            <c:showVal val="1"/>
-            <c:showCatName val="0"/>
-            <c:showSerName val="0"/>
-            <c:showPercent val="0"/>
-            <c:showBubbleSize val="0"/>
-            <c:showLeaderLines val="0"/>
-          </c:dLbls>
-          <c:dPt>
-            <c:idx val="0"/>
-            <c:invertIfNegative val="0"/>
-            <c:bubble3D val="0"/>
-            <c:spPr>
-              <a:solidFill>
-                <a:srgbClr val="333333"/>
-              </a:solidFill>
-              <a:effectLst/>
-            </c:spPr>
-          </c:dPt>
-          <c:dPt>
-            <c:idx val="1"/>
-            <c:invertIfNegative val="0"/>
-            <c:bubble3D val="0"/>
-            <c:spPr>
-              <a:solidFill>
-                <a:srgbClr val="333333"/>
-              </a:solidFill>
-              <a:effectLst/>
-            </c:spPr>
-          </c:dPt>
-          <c:dPt>
-            <c:idx val="2"/>
-            <c:invertIfNegative val="0"/>
-            <c:bubble3D val="0"/>
-            <c:spPr>
-              <a:solidFill>
-                <a:srgbClr val="333333"/>
-              </a:solidFill>
-              <a:effectLst/>
-            </c:spPr>
-          </c:dPt>
-          <c:dPt>
-            <c:idx val="3"/>
-            <c:invertIfNegative val="0"/>
-            <c:bubble3D val="0"/>
-            <c:spPr>
-              <a:solidFill>
-                <a:srgbClr val="333333"/>
-              </a:solidFill>
-              <a:effectLst/>
-            </c:spPr>
-          </c:dPt>
-          <c:cat>
-            <c:multiLvlStrRef>
-              <c:f>Sheet1!$A$2:$A$5</c:f>
-              <c:multiLvlStrCache>
-                <c:ptCount val="4"/>
-                <c:lvl>
-                  <c:pt idx="0">
-                    <c:v>FCFS</c:v>
-                  </c:pt>
-                  <c:pt idx="1">
-                    <c:v>Priority</c:v>
-                  </c:pt>
-                  <c:pt idx="2">
-                    <c:v>MLFQ</c:v>
-                  </c:pt>
-                  <c:pt idx="3">
-                    <c:v>WFQ</c:v>
-                  </c:pt>
-                </c:lvl>
-              </c:multiLvlStrCache>
-            </c:multiLvlStrRef>
-          </c:cat>
-          <c:val>
-            <c:numRef>
-              <c:f>Sheet1!$B$2:$B$5</c:f>
-              <c:numCache>
-                <c:formatCode>General</c:formatCode>
-                <c:ptCount val="4"/>
-                <c:pt idx="0">
-                  <c:v>12203</c:v>
-                </c:pt>
-                <c:pt idx="1">
-                  <c:v>12419</c:v>
-                </c:pt>
-                <c:pt idx="2">
-                  <c:v>12203</c:v>
-                </c:pt>
-                <c:pt idx="3">
-                  <c:v>11846</c:v>
-                </c:pt>
-              </c:numCache>
-            </c:numRef>
-          </c:val>
-        </c:ser>
-        <c:dLbls>
-          <c:numFmt formatCode="#,##0" sourceLinked="0"/>
-          <c:txPr>
-            <a:bodyPr/>
-            <a:lstStyle/>
-            <a:p>
-              <a:pPr>
-                <a:defRPr b="0" i="0" strike="noStrike" sz="1000" u="none">
-                  <a:solidFill>
-                    <a:srgbClr val="000000"/>
-                  </a:solidFill>
-                  <a:latin typeface="Arial"/>
-                </a:defRPr>
-              </a:pPr>
-            </a:p>
-          </c:txPr>
-          <c:showLegendKey val="0"/>
-          <c:showVal val="1"/>
-          <c:showCatName val="0"/>
-          <c:showSerName val="0"/>
-          <c:showPercent val="0"/>
-          <c:showBubbleSize val="0"/>
-          <c:showLeaderLines val="0"/>
-        </c:dLbls>
-        <c:gapWidth val="150"/>
-        <c:overlap val="0"/>
-        <c:axId val="2094734554"/>
-        <c:axId val="2094734552"/>
-        <c:axId val="2094734556"/>
-      </c:barChart>
-      <c:catAx>
-        <c:axId val="2094734554"/>
-        <c:scaling>
-          <c:orientation val="minMax"/>
-        </c:scaling>
-        <c:delete val="0"/>
-        <c:axPos val="b"/>
-        <c:numFmt formatCode="General" sourceLinked="1"/>
-        <c:majorTickMark val="out"/>
-        <c:minorTickMark val="none"/>
-        <c:tickLblPos val="low"/>
-        <c:spPr>
-          <a:ln w="12700" cap="flat">
-            <a:solidFill>
-              <a:srgbClr val="888888"/>
-            </a:solidFill>
-            <a:prstDash val="solid"/>
-            <a:round/>
-          </a:ln>
-        </c:spPr>
-        <c:txPr>
-          <a:bodyPr/>
-          <a:lstStyle/>
-          <a:p>
-            <a:pPr>
-              <a:defRPr sz="1100" b="0" i="0" u="none" strike="noStrike">
-                <a:solidFill>
-                  <a:srgbClr val="000000"/>
-                </a:solidFill>
-                <a:latin typeface="Arial"/>
-              </a:defRPr>
-            </a:pPr>
-            <a:endParaRPr lang="en-US"/>
-          </a:p>
-        </c:txPr>
-        <c:crossAx val="2094734552"/>
-        <c:crosses val="autoZero"/>
-        <c:auto val="1"/>
-        <c:lblAlgn val="ctr"/>
-        <c:noMultiLvlLbl val="1"/>
-      </c:catAx>
-      <c:valAx>
-        <c:axId val="2094734552"/>
-        <c:scaling>
-          <c:orientation val="minMax"/>
-        </c:scaling>
-        <c:delete val="0"/>
-        <c:axPos val="l"/>
-        <c:majorGridlines>
-          <c:spPr>
-            <a:ln w="6350" cap="flat">
-              <a:solidFill>
-                <a:srgbClr val="DDDDDD"/>
-              </a:solidFill>
-              <a:prstDash val="dot"/>
-              <a:round/>
-            </a:ln>
-          </c:spPr>
-        </c:majorGridlines>
-        <c:numFmt formatCode="General" sourceLinked="0"/>
-        <c:majorTickMark val="out"/>
-        <c:minorTickMark val="none"/>
-        <c:tickLblPos val="nextTo"/>
-        <c:spPr>
-          <a:ln w="12700" cap="flat">
-            <a:solidFill>
-              <a:srgbClr val="888888"/>
-            </a:solidFill>
-            <a:prstDash val="solid"/>
-            <a:round/>
-          </a:ln>
-        </c:spPr>
-        <c:txPr>
-          <a:bodyPr/>
-          <a:lstStyle/>
-          <a:p>
-            <a:pPr>
-              <a:defRPr sz="900" b="0" i="0" u="none" strike="noStrike">
-                <a:solidFill>
-                  <a:srgbClr val="000000"/>
-                </a:solidFill>
-                <a:latin typeface="Arial"/>
-              </a:defRPr>
-            </a:pPr>
-            <a:endParaRPr lang="en-US"/>
-          </a:p>
-        </c:txPr>
-        <c:crossAx val="2094734554"/>
-        <c:crosses val="autoZero"/>
-        <c:crossBetween val="between"/>
-      </c:valAx>
-      <c:spPr>
-        <a:noFill/>
-        <a:ln>
-          <a:noFill/>
-        </a:ln>
-        <a:effectLst/>
-      </c:spPr>
-    </c:plotArea>
-    <c:plotVisOnly val="1"/>
-    <c:dispBlanksAs val="span"/>
-  </c:chart>
-  <c:spPr>
-    <a:noFill/>
-    <a:ln>
-      <a:noFill/>
-    </a:ln>
-    <a:effectLst/>
-  </c:spPr>
-  <c:externalData r:id="rId1">
-    <c:autoUpdate val="0"/>
-  </c:externalData>
-</c:chartSpace>
-</file>
-
-<file path=ppt/charts/chart6.xml><?xml version="1.0" encoding="utf-8"?>
+<file path=ppt/charts/chart3.xml><?xml version="1.0" encoding="utf-8"?>
 <c:chartSpace xmlns:c="http://schemas.openxmlformats.org/drawingml/2006/chart" xmlns:a="http://schemas.openxmlformats.org/drawingml/2006/main" xmlns:r="http://schemas.openxmlformats.org/officeDocument/2006/relationships">
   <c:date1904 val="0"/>
   <c:roundedCorners val="1"/>
@@ -740,7 +448,7 @@
 </c:chartSpace>
 </file>
 
-<file path=ppt/charts/chart7.xml><?xml version="1.0" encoding="utf-8"?>
+<file path=ppt/charts/chart4.xml><?xml version="1.0" encoding="utf-8"?>
 <c:chartSpace xmlns:c="http://schemas.openxmlformats.org/drawingml/2006/chart" xmlns:a="http://schemas.openxmlformats.org/drawingml/2006/main" xmlns:r="http://schemas.openxmlformats.org/officeDocument/2006/relationships">
   <c:date1904 val="0"/>
   <c:roundedCorners val="1"/>
@@ -1162,298 +870,6 @@
         </a:p>
       </c:txPr>
     </c:legend>
-    <c:plotVisOnly val="1"/>
-    <c:dispBlanksAs val="span"/>
-  </c:chart>
-  <c:spPr>
-    <a:noFill/>
-    <a:ln>
-      <a:noFill/>
-    </a:ln>
-    <a:effectLst/>
-  </c:spPr>
-  <c:externalData r:id="rId1">
-    <c:autoUpdate val="0"/>
-  </c:externalData>
-</c:chartSpace>
-</file>
-
-<file path=ppt/charts/chart8.xml><?xml version="1.0" encoding="utf-8"?>
-<c:chartSpace xmlns:c="http://schemas.openxmlformats.org/drawingml/2006/chart" xmlns:a="http://schemas.openxmlformats.org/drawingml/2006/main" xmlns:r="http://schemas.openxmlformats.org/officeDocument/2006/relationships">
-  <c:date1904 val="0"/>
-  <c:roundedCorners val="1"/>
-  <c:chart>
-    <c:autoTitleDeleted val="1"/>
-    <c:plotArea>
-      <c:layout/>
-      <c:barChart>
-        <c:barDir val="col"/>
-        <c:grouping val="clustered"/>
-        <c:varyColors val="0"/>
-        <c:ser>
-          <c:idx val="0"/>
-          <c:order val="0"/>
-          <c:tx>
-            <c:strRef>
-              <c:f>Sheet1!$B$1</c:f>
-              <c:strCache>
-                <c:ptCount val="1"/>
-                <c:pt idx="0">
-                  <c:v>JFI (Jain's Fairness Index)</c:v>
-                </c:pt>
-              </c:strCache>
-            </c:strRef>
-          </c:tx>
-          <c:spPr>
-            <a:solidFill>
-              <a:srgbClr val="333333"/>
-            </a:solidFill>
-            <a:effectLst/>
-          </c:spPr>
-          <c:invertIfNegative val="0"/>
-          <c:dLbls>
-            <c:numFmt formatCode="#,##0" sourceLinked="0"/>
-            <c:txPr>
-              <a:bodyPr/>
-              <a:lstStyle/>
-              <a:p>
-                <a:pPr>
-                  <a:defRPr b="0" i="0" strike="noStrike" sz="1100" u="none">
-                    <a:solidFill>
-                      <a:srgbClr val="000000"/>
-                    </a:solidFill>
-                    <a:latin typeface="Arial"/>
-                  </a:defRPr>
-                </a:pPr>
-              </a:p>
-            </c:txPr>
-            <c:showLegendKey val="0"/>
-            <c:showVal val="1"/>
-            <c:showCatName val="0"/>
-            <c:showSerName val="0"/>
-            <c:showPercent val="0"/>
-            <c:showBubbleSize val="0"/>
-            <c:showLeaderLines val="0"/>
-          </c:dLbls>
-          <c:dPt>
-            <c:idx val="0"/>
-            <c:invertIfNegative val="0"/>
-            <c:bubble3D val="0"/>
-            <c:spPr>
-              <a:solidFill>
-                <a:srgbClr val="333333"/>
-              </a:solidFill>
-              <a:effectLst/>
-            </c:spPr>
-          </c:dPt>
-          <c:dPt>
-            <c:idx val="1"/>
-            <c:invertIfNegative val="0"/>
-            <c:bubble3D val="0"/>
-            <c:spPr>
-              <a:solidFill>
-                <a:srgbClr val="333333"/>
-              </a:solidFill>
-              <a:effectLst/>
-            </c:spPr>
-          </c:dPt>
-          <c:dPt>
-            <c:idx val="2"/>
-            <c:invertIfNegative val="0"/>
-            <c:bubble3D val="0"/>
-            <c:spPr>
-              <a:solidFill>
-                <a:srgbClr val="333333"/>
-              </a:solidFill>
-              <a:effectLst/>
-            </c:spPr>
-          </c:dPt>
-          <c:dPt>
-            <c:idx val="3"/>
-            <c:invertIfNegative val="0"/>
-            <c:bubble3D val="0"/>
-            <c:spPr>
-              <a:solidFill>
-                <a:srgbClr val="333333"/>
-              </a:solidFill>
-              <a:effectLst/>
-            </c:spPr>
-          </c:dPt>
-          <c:cat>
-            <c:multiLvlStrRef>
-              <c:f>Sheet1!$A$2:$A$5</c:f>
-              <c:multiLvlStrCache>
-                <c:ptCount val="4"/>
-                <c:lvl>
-                  <c:pt idx="0">
-                    <c:v>FCFS</c:v>
-                  </c:pt>
-                  <c:pt idx="1">
-                    <c:v>Priority</c:v>
-                  </c:pt>
-                  <c:pt idx="2">
-                    <c:v>MLFQ</c:v>
-                  </c:pt>
-                  <c:pt idx="3">
-                    <c:v>WFQ</c:v>
-                  </c:pt>
-                </c:lvl>
-              </c:multiLvlStrCache>
-            </c:multiLvlStrRef>
-          </c:cat>
-          <c:val>
-            <c:numRef>
-              <c:f>Sheet1!$B$2:$B$5</c:f>
-              <c:numCache>
-                <c:formatCode>General</c:formatCode>
-                <c:ptCount val="4"/>
-                <c:pt idx="0">
-                  <c:v>1</c:v>
-                </c:pt>
-                <c:pt idx="1">
-                  <c:v>1</c:v>
-                </c:pt>
-                <c:pt idx="2">
-                  <c:v>1</c:v>
-                </c:pt>
-                <c:pt idx="3">
-                  <c:v>0.316</c:v>
-                </c:pt>
-              </c:numCache>
-            </c:numRef>
-          </c:val>
-        </c:ser>
-        <c:dLbls>
-          <c:numFmt formatCode="#,##0" sourceLinked="0"/>
-          <c:txPr>
-            <a:bodyPr/>
-            <a:lstStyle/>
-            <a:p>
-              <a:pPr>
-                <a:defRPr b="0" i="0" strike="noStrike" sz="1100" u="none">
-                  <a:solidFill>
-                    <a:srgbClr val="000000"/>
-                  </a:solidFill>
-                  <a:latin typeface="Arial"/>
-                </a:defRPr>
-              </a:pPr>
-            </a:p>
-          </c:txPr>
-          <c:showLegendKey val="0"/>
-          <c:showVal val="1"/>
-          <c:showCatName val="0"/>
-          <c:showSerName val="0"/>
-          <c:showPercent val="0"/>
-          <c:showBubbleSize val="0"/>
-          <c:showLeaderLines val="0"/>
-        </c:dLbls>
-        <c:gapWidth val="150"/>
-        <c:overlap val="0"/>
-        <c:axId val="2094734554"/>
-        <c:axId val="2094734552"/>
-        <c:axId val="2094734556"/>
-      </c:barChart>
-      <c:catAx>
-        <c:axId val="2094734554"/>
-        <c:scaling>
-          <c:orientation val="minMax"/>
-        </c:scaling>
-        <c:delete val="0"/>
-        <c:axPos val="b"/>
-        <c:numFmt formatCode="General" sourceLinked="1"/>
-        <c:majorTickMark val="out"/>
-        <c:minorTickMark val="none"/>
-        <c:tickLblPos val="low"/>
-        <c:spPr>
-          <a:ln w="12700" cap="flat">
-            <a:solidFill>
-              <a:srgbClr val="888888"/>
-            </a:solidFill>
-            <a:prstDash val="solid"/>
-            <a:round/>
-          </a:ln>
-        </c:spPr>
-        <c:txPr>
-          <a:bodyPr/>
-          <a:lstStyle/>
-          <a:p>
-            <a:pPr>
-              <a:defRPr sz="1200" b="0" i="0" u="none" strike="noStrike">
-                <a:solidFill>
-                  <a:srgbClr val="000000"/>
-                </a:solidFill>
-                <a:latin typeface="Arial"/>
-              </a:defRPr>
-            </a:pPr>
-            <a:endParaRPr lang="en-US"/>
-          </a:p>
-        </c:txPr>
-        <c:crossAx val="2094734552"/>
-        <c:crosses val="autoZero"/>
-        <c:auto val="1"/>
-        <c:lblAlgn val="ctr"/>
-        <c:noMultiLvlLbl val="1"/>
-      </c:catAx>
-      <c:valAx>
-        <c:axId val="2094734552"/>
-        <c:scaling>
-          <c:orientation val="minMax"/>
-          <c:max val="1.2"/>
-          <c:min val="0"/>
-        </c:scaling>
-        <c:delete val="0"/>
-        <c:axPos val="l"/>
-        <c:majorGridlines>
-          <c:spPr>
-            <a:ln w="6350" cap="flat">
-              <a:solidFill>
-                <a:srgbClr val="DDDDDD"/>
-              </a:solidFill>
-              <a:prstDash val="dot"/>
-              <a:round/>
-            </a:ln>
-          </c:spPr>
-        </c:majorGridlines>
-        <c:numFmt formatCode="General" sourceLinked="0"/>
-        <c:majorTickMark val="out"/>
-        <c:minorTickMark val="none"/>
-        <c:tickLblPos val="nextTo"/>
-        <c:spPr>
-          <a:ln w="12700" cap="flat">
-            <a:solidFill>
-              <a:srgbClr val="888888"/>
-            </a:solidFill>
-            <a:prstDash val="solid"/>
-            <a:round/>
-          </a:ln>
-        </c:spPr>
-        <c:txPr>
-          <a:bodyPr/>
-          <a:lstStyle/>
-          <a:p>
-            <a:pPr>
-              <a:defRPr sz="900" b="0" i="0" u="none" strike="noStrike">
-                <a:solidFill>
-                  <a:srgbClr val="000000"/>
-                </a:solidFill>
-                <a:latin typeface="Arial"/>
-              </a:defRPr>
-            </a:pPr>
-            <a:endParaRPr lang="en-US"/>
-          </a:p>
-        </c:txPr>
-        <c:crossAx val="2094734554"/>
-        <c:crosses val="autoZero"/>
-        <c:crossBetween val="between"/>
-      </c:valAx>
-      <c:spPr>
-        <a:noFill/>
-        <a:ln>
-          <a:noFill/>
-        </a:ln>
-        <a:effectLst/>
-      </c:spPr>
-    </c:plotArea>
     <c:plotVisOnly val="1"/>
     <c:dispBlanksAs val="span"/>
   </c:chart>
@@ -2259,182 +1675,6 @@
 </p:notes>
 </file>
 
-<file path=ppt/notesSlides/notesSlide6.xml><?xml version="1.0" encoding="utf-8"?>
-<p:notes xmlns:a="http://schemas.openxmlformats.org/drawingml/2006/main" xmlns:r="http://schemas.openxmlformats.org/officeDocument/2006/relationships" xmlns:p="http://schemas.openxmlformats.org/presentationml/2006/main">
-  <p:cSld>
-    <p:spTree>
-      <p:nvGrpSpPr>
-        <p:cNvPr id="1" name=""/>
-        <p:cNvGrpSpPr/>
-        <p:nvPr/>
-      </p:nvGrpSpPr>
-      <p:grpSpPr>
-        <a:xfrm>
-          <a:off x="0" y="0"/>
-          <a:ext cx="0" cy="0"/>
-          <a:chOff x="0" y="0"/>
-          <a:chExt cx="0" cy="0"/>
-        </a:xfrm>
-      </p:grpSpPr>
-      <p:sp>
-        <p:nvSpPr>
-          <p:cNvPr id="2" name="Slide Image Placeholder 1"/>
-          <p:cNvSpPr>
-            <a:spLocks noGrp="1" noRot="1" noChangeAspect="1"/>
-          </p:cNvSpPr>
-          <p:nvPr>
-            <p:ph type="sldImg"/>
-          </p:nvPr>
-        </p:nvSpPr>
-        <p:spPr/>
-      </p:sp>
-      <p:sp>
-        <p:nvSpPr>
-          <p:cNvPr id="3" name="Notes Placeholder 2"/>
-          <p:cNvSpPr>
-            <a:spLocks noGrp="1"/>
-          </p:cNvSpPr>
-          <p:nvPr>
-            <p:ph type="body" idx="1"/>
-          </p:nvPr>
-        </p:nvSpPr>
-        <p:spPr/>
-        <p:txBody>
-          <a:bodyPr/>
-          <a:lstStyle/>
-          <a:p>
-            <a:r>
-              <a:rPr lang="en-US" dirty="0"/>
-              <a:t/>
-            </a:r>
-            <a:endParaRPr lang="en-US" dirty="0"/>
-          </a:p>
-        </p:txBody>
-      </p:sp>
-      <p:sp>
-        <p:nvSpPr>
-          <p:cNvPr id="4" name="Slide Number Placeholder 3"/>
-          <p:cNvSpPr>
-            <a:spLocks noGrp="1"/>
-          </p:cNvSpPr>
-          <p:nvPr>
-            <p:ph type="sldNum" sz="quarter" idx="10"/>
-          </p:nvPr>
-        </p:nvSpPr>
-        <p:spPr/>
-        <p:txBody>
-          <a:bodyPr/>
-          <a:lstStyle/>
-          <a:p>
-            <a:fld id="{F7021451-1387-4CA6-816F-3879F97B5CBC}" type="slidenum">
-              <a:rPr lang="en-US"/>
-              <a:t>6</a:t>
-            </a:fld>
-            <a:endParaRPr lang="en-US"/>
-          </a:p>
-        </p:txBody>
-      </p:sp>
-    </p:spTree>
-    <p:extLst>
-      <p:ext uri="{BB962C8B-B14F-4D97-AF65-F5344CB8AC3E}">
-        <p14:creationId xmlns:p14="http://schemas.microsoft.com/office/powerpoint/2010/main" val="1024086991"/>
-      </p:ext>
-    </p:extLst>
-  </p:cSld>
-  <p:clrMapOvr>
-    <a:masterClrMapping/>
-  </p:clrMapOvr>
-</p:notes>
-</file>
-
-<file path=ppt/notesSlides/notesSlide7.xml><?xml version="1.0" encoding="utf-8"?>
-<p:notes xmlns:a="http://schemas.openxmlformats.org/drawingml/2006/main" xmlns:r="http://schemas.openxmlformats.org/officeDocument/2006/relationships" xmlns:p="http://schemas.openxmlformats.org/presentationml/2006/main">
-  <p:cSld>
-    <p:spTree>
-      <p:nvGrpSpPr>
-        <p:cNvPr id="1" name=""/>
-        <p:cNvGrpSpPr/>
-        <p:nvPr/>
-      </p:nvGrpSpPr>
-      <p:grpSpPr>
-        <a:xfrm>
-          <a:off x="0" y="0"/>
-          <a:ext cx="0" cy="0"/>
-          <a:chOff x="0" y="0"/>
-          <a:chExt cx="0" cy="0"/>
-        </a:xfrm>
-      </p:grpSpPr>
-      <p:sp>
-        <p:nvSpPr>
-          <p:cNvPr id="2" name="Slide Image Placeholder 1"/>
-          <p:cNvSpPr>
-            <a:spLocks noGrp="1" noRot="1" noChangeAspect="1"/>
-          </p:cNvSpPr>
-          <p:nvPr>
-            <p:ph type="sldImg"/>
-          </p:nvPr>
-        </p:nvSpPr>
-        <p:spPr/>
-      </p:sp>
-      <p:sp>
-        <p:nvSpPr>
-          <p:cNvPr id="3" name="Notes Placeholder 2"/>
-          <p:cNvSpPr>
-            <a:spLocks noGrp="1"/>
-          </p:cNvSpPr>
-          <p:nvPr>
-            <p:ph type="body" idx="1"/>
-          </p:nvPr>
-        </p:nvSpPr>
-        <p:spPr/>
-        <p:txBody>
-          <a:bodyPr/>
-          <a:lstStyle/>
-          <a:p>
-            <a:r>
-              <a:rPr lang="en-US" dirty="0"/>
-              <a:t/>
-            </a:r>
-            <a:endParaRPr lang="en-US" dirty="0"/>
-          </a:p>
-        </p:txBody>
-      </p:sp>
-      <p:sp>
-        <p:nvSpPr>
-          <p:cNvPr id="4" name="Slide Number Placeholder 3"/>
-          <p:cNvSpPr>
-            <a:spLocks noGrp="1"/>
-          </p:cNvSpPr>
-          <p:nvPr>
-            <p:ph type="sldNum" sz="quarter" idx="10"/>
-          </p:nvPr>
-        </p:nvSpPr>
-        <p:spPr/>
-        <p:txBody>
-          <a:bodyPr/>
-          <a:lstStyle/>
-          <a:p>
-            <a:fld id="{F7021451-1387-4CA6-816F-3879F97B5CBC}" type="slidenum">
-              <a:rPr lang="en-US"/>
-              <a:t>7</a:t>
-            </a:fld>
-            <a:endParaRPr lang="en-US"/>
-          </a:p>
-        </p:txBody>
-      </p:sp>
-    </p:spTree>
-    <p:extLst>
-      <p:ext uri="{BB962C8B-B14F-4D97-AF65-F5344CB8AC3E}">
-        <p14:creationId xmlns:p14="http://schemas.microsoft.com/office/powerpoint/2010/main" val="1024086991"/>
-      </p:ext>
-    </p:extLst>
-  </p:cSld>
-  <p:clrMapOvr>
-    <a:masterClrMapping/>
-  </p:clrMapOvr>
-</p:notes>
-</file>
-
 <file path=ppt/slideLayouts/slideLayout1.xml><?xml version="1.0" encoding="utf-8"?>
 <p:sldLayout xmlns:a="http://schemas.openxmlformats.org/drawingml/2006/main" xmlns:r="http://schemas.openxmlformats.org/officeDocument/2006/relationships" xmlns:p="http://schemas.openxmlformats.org/presentationml/2006/main" preserve="1">
   <p:cSld name="DEFAULT">
@@ -2792,7 +2032,7 @@
                 <a:ea typeface="맑은 고딕" pitchFamily="34" charset="-122"/>
                 <a:cs typeface="맑은 고딕" pitchFamily="34" charset="-120"/>
               </a:rPr>
-              <a:t>그림 2. 시스템 아키텍처 (System Architecture)</a:t>
+              <a:t>그림 1. 시스템 아키텍처 (System Architecture)</a:t>
             </a:r>
             <a:endParaRPr lang="en-US" sz="1400" dirty="0"/>
           </a:p>
@@ -4478,7 +3718,7 @@
                 <a:ea typeface="맑은 고딕" pitchFamily="34" charset="-122"/>
                 <a:cs typeface="맑은 고딕" pitchFamily="34" charset="-120"/>
               </a:rPr>
-              <a:t>그림 3. 데이터 흐름도 (Data Flow)</a:t>
+              <a:t>그림 2. 데이터 흐름도 (Data Flow)</a:t>
             </a:r>
             <a:endParaRPr lang="en-US" sz="1400" dirty="0"/>
           </a:p>
@@ -7107,7 +6347,7 @@
                 <a:ea typeface="맑은 고딕" pitchFamily="34" charset="-122"/>
                 <a:cs typeface="맑은 고딕" pitchFamily="34" charset="-120"/>
               </a:rPr>
-              <a:t>그림 6. 알고리즘별 평균 대기시간 비교 (ms)</a:t>
+              <a:t>그림 4. MLFQ 선점형 vs FCFS — 요청 유형별 응답시간</a:t>
             </a:r>
             <a:endParaRPr lang="en-US" sz="1400" dirty="0"/>
           </a:p>
@@ -7146,7 +6386,7 @@
                 <a:ea typeface="맑은 고딕" pitchFamily="34" charset="-122"/>
                 <a:cs typeface="맑은 고딕" pitchFamily="34" charset="-120"/>
               </a:rPr>
-              <a:t>기본 실험 500건 | 4명 (등급별 1명) | 순차 도착</a:t>
+              <a:t>5시드 평균 | 버스트 패턴 | 단위: 초(s)</a:t>
             </a:r>
             <a:endParaRPr lang="en-US" sz="900" dirty="0"/>
           </a:p>
@@ -7160,7 +6400,7 @@
         </p:nvGraphicFramePr>
         <p:xfrm>
           <a:off x="457200" y="777240"/>
-          <a:ext cx="8229600" cy="3977640"/>
+          <a:ext cx="7772400" cy="3977640"/>
         </p:xfrm>
         <a:graphic xmlns:a="http://schemas.openxmlformats.org/drawingml/2006/main">
           <a:graphicData uri="http://schemas.openxmlformats.org/drawingml/2006/chart">
@@ -7226,126 +6466,7 @@
                 <a:ea typeface="맑은 고딕" pitchFamily="34" charset="-122"/>
                 <a:cs typeface="맑은 고딕" pitchFamily="34" charset="-120"/>
               </a:rPr>
-              <a:t>그림 7. MLFQ 선점형 vs FCFS — 요청 유형별 응답시간</a:t>
-            </a:r>
-            <a:endParaRPr lang="en-US" sz="1400" dirty="0"/>
-          </a:p>
-        </p:txBody>
-      </p:sp>
-      <p:sp>
-        <p:nvSpPr>
-          <p:cNvPr id="3" name="Text 1"/>
-          <p:cNvSpPr/>
-          <p:nvPr/>
-        </p:nvSpPr>
-        <p:spPr>
-          <a:xfrm>
-            <a:off x="274320" y="475488"/>
-            <a:ext cx="8595360" cy="228600"/>
-          </a:xfrm>
-          <a:prstGeom prst="rect">
-            <a:avLst/>
-          </a:prstGeom>
-          <a:noFill/>
-          <a:ln/>
-        </p:spPr>
-        <p:txBody>
-          <a:bodyPr wrap="square" rtlCol="0" anchor="ctr"/>
-          <a:lstStyle/>
-          <a:p>
-            <a:pPr indent="0" marL="0">
-              <a:buNone/>
-            </a:pPr>
-            <a:r>
-              <a:rPr lang="en-US" sz="900" dirty="0">
-                <a:solidFill>
-                  <a:srgbClr val="333333"/>
-                </a:solidFill>
-                <a:latin typeface="맑은 고딕" pitchFamily="34" charset="0"/>
-                <a:ea typeface="맑은 고딕" pitchFamily="34" charset="-122"/>
-                <a:cs typeface="맑은 고딕" pitchFamily="34" charset="-120"/>
-              </a:rPr>
-              <a:t>5시드 평균 | 버스트 패턴 | 단위: 초(s)</a:t>
-            </a:r>
-            <a:endParaRPr lang="en-US" sz="900" dirty="0"/>
-          </a:p>
-        </p:txBody>
-      </p:sp>
-      <p:graphicFrame>
-        <p:nvGraphicFramePr>
-          <p:cNvPr id="4" name="Chart 0" descr=""/>
-          <p:cNvGraphicFramePr/>
-          <p:nvPr/>
-        </p:nvGraphicFramePr>
-        <p:xfrm>
-          <a:off x="457200" y="777240"/>
-          <a:ext cx="7772400" cy="3977640"/>
-        </p:xfrm>
-        <a:graphic xmlns:a="http://schemas.openxmlformats.org/drawingml/2006/main">
-          <a:graphicData uri="http://schemas.openxmlformats.org/drawingml/2006/chart">
-            <c:chart xmlns:c="http://schemas.openxmlformats.org/drawingml/2006/chart" r:id="rId1"/>
-          </a:graphicData>
-        </a:graphic>
-      </p:graphicFrame>
-    </p:spTree>
-  </p:cSld>
-  <p:clrMapOvr>
-    <a:masterClrMapping/>
-  </p:clrMapOvr>
-</p:sld>
-</file>
-
-<file path=ppt/slides/slide6.xml><?xml version="1.0" encoding="utf-8"?>
-<p:sld xmlns:a="http://schemas.openxmlformats.org/drawingml/2006/main" xmlns:r="http://schemas.openxmlformats.org/officeDocument/2006/relationships" xmlns:p="http://schemas.openxmlformats.org/presentationml/2006/main">
-  <p:cSld name="Slide 6">
-    <p:spTree>
-      <p:nvGrpSpPr>
-        <p:cNvPr id="1" name=""/>
-        <p:cNvGrpSpPr/>
-        <p:nvPr/>
-      </p:nvGrpSpPr>
-      <p:grpSpPr>
-        <a:xfrm>
-          <a:off x="0" y="0"/>
-          <a:ext cx="0" cy="0"/>
-          <a:chOff x="0" y="0"/>
-          <a:chExt cx="0" cy="0"/>
-        </a:xfrm>
-      </p:grpSpPr>
-      <p:sp>
-        <p:nvSpPr>
-          <p:cNvPr id="2" name="Text 0"/>
-          <p:cNvSpPr/>
-          <p:nvPr/>
-        </p:nvSpPr>
-        <p:spPr>
-          <a:xfrm>
-            <a:off x="274320" y="91440"/>
-            <a:ext cx="8595360" cy="411480"/>
-          </a:xfrm>
-          <a:prstGeom prst="rect">
-            <a:avLst/>
-          </a:prstGeom>
-          <a:noFill/>
-          <a:ln/>
-        </p:spPr>
-        <p:txBody>
-          <a:bodyPr wrap="square" rtlCol="0" anchor="ctr"/>
-          <a:lstStyle/>
-          <a:p>
-            <a:pPr algn="ctr" indent="0" marL="0">
-              <a:buNone/>
-            </a:pPr>
-            <a:r>
-              <a:rPr lang="en-US" sz="1400" b="1" dirty="0">
-                <a:solidFill>
-                  <a:srgbClr val="000000"/>
-                </a:solidFill>
-                <a:latin typeface="맑은 고딕" pitchFamily="34" charset="0"/>
-                <a:ea typeface="맑은 고딕" pitchFamily="34" charset="-122"/>
-                <a:cs typeface="맑은 고딕" pitchFamily="34" charset="-120"/>
-              </a:rPr>
-              <a:t>그림 8. 실서버 구독 등급별 평균 대기시간 (ms)</a:t>
+              <a:t>그림 5. 실서버 구독 등급별 평균 대기시간 (ms)</a:t>
             </a:r>
             <a:endParaRPr lang="en-US" sz="1400" dirty="0"/>
           </a:p>
@@ -7406,164 +6527,6 @@
           </a:graphicData>
         </a:graphic>
       </p:graphicFrame>
-    </p:spTree>
-  </p:cSld>
-  <p:clrMapOvr>
-    <a:masterClrMapping/>
-  </p:clrMapOvr>
-</p:sld>
-</file>
-
-<file path=ppt/slides/slide7.xml><?xml version="1.0" encoding="utf-8"?>
-<p:sld xmlns:a="http://schemas.openxmlformats.org/drawingml/2006/main" xmlns:r="http://schemas.openxmlformats.org/officeDocument/2006/relationships" xmlns:p="http://schemas.openxmlformats.org/presentationml/2006/main">
-  <p:cSld name="Slide 7">
-    <p:spTree>
-      <p:nvGrpSpPr>
-        <p:cNvPr id="1" name=""/>
-        <p:cNvGrpSpPr/>
-        <p:nvPr/>
-      </p:nvGrpSpPr>
-      <p:grpSpPr>
-        <a:xfrm>
-          <a:off x="0" y="0"/>
-          <a:ext cx="0" cy="0"/>
-          <a:chOff x="0" y="0"/>
-          <a:chExt cx="0" cy="0"/>
-        </a:xfrm>
-      </p:grpSpPr>
-      <p:sp>
-        <p:nvSpPr>
-          <p:cNvPr id="2" name="Text 0"/>
-          <p:cNvSpPr/>
-          <p:nvPr/>
-        </p:nvSpPr>
-        <p:spPr>
-          <a:xfrm>
-            <a:off x="274320" y="91440"/>
-            <a:ext cx="8595360" cy="411480"/>
-          </a:xfrm>
-          <a:prstGeom prst="rect">
-            <a:avLst/>
-          </a:prstGeom>
-          <a:noFill/>
-          <a:ln/>
-        </p:spPr>
-        <p:txBody>
-          <a:bodyPr wrap="square" rtlCol="0" anchor="ctr"/>
-          <a:lstStyle/>
-          <a:p>
-            <a:pPr algn="ctr" indent="0" marL="0">
-              <a:buNone/>
-            </a:pPr>
-            <a:r>
-              <a:rPr lang="en-US" sz="1400" b="1" dirty="0">
-                <a:solidFill>
-                  <a:srgbClr val="000000"/>
-                </a:solidFill>
-                <a:latin typeface="맑은 고딕" pitchFamily="34" charset="0"/>
-                <a:ea typeface="맑은 고딕" pitchFamily="34" charset="-122"/>
-                <a:cs typeface="맑은 고딕" pitchFamily="34" charset="-120"/>
-              </a:rPr>
-              <a:t>그림 9. 알고리즘별 Jain's Fairness Index (JFI) 비교</a:t>
-            </a:r>
-            <a:endParaRPr lang="en-US" sz="1400" dirty="0"/>
-          </a:p>
-        </p:txBody>
-      </p:sp>
-      <p:sp>
-        <p:nvSpPr>
-          <p:cNvPr id="3" name="Text 1"/>
-          <p:cNvSpPr/>
-          <p:nvPr/>
-        </p:nvSpPr>
-        <p:spPr>
-          <a:xfrm>
-            <a:off x="274320" y="475488"/>
-            <a:ext cx="8595360" cy="228600"/>
-          </a:xfrm>
-          <a:prstGeom prst="rect">
-            <a:avLst/>
-          </a:prstGeom>
-          <a:noFill/>
-          <a:ln/>
-        </p:spPr>
-        <p:txBody>
-          <a:bodyPr wrap="square" rtlCol="0" anchor="ctr"/>
-          <a:lstStyle/>
-          <a:p>
-            <a:pPr indent="0" marL="0">
-              <a:buNone/>
-            </a:pPr>
-            <a:r>
-              <a:rPr lang="en-US" sz="900" dirty="0">
-                <a:solidFill>
-                  <a:srgbClr val="333333"/>
-                </a:solidFill>
-                <a:latin typeface="맑은 고딕" pitchFamily="34" charset="0"/>
-                <a:ea typeface="맑은 고딕" pitchFamily="34" charset="-122"/>
-                <a:cs typeface="맑은 고딕" pitchFamily="34" charset="-120"/>
-              </a:rPr>
-              <a:t>JFI = 1.0이 완전 공정, 낮을수록 불공평</a:t>
-            </a:r>
-            <a:endParaRPr lang="en-US" sz="900" dirty="0"/>
-          </a:p>
-        </p:txBody>
-      </p:sp>
-      <p:graphicFrame>
-        <p:nvGraphicFramePr>
-          <p:cNvPr id="4" name="Chart 0" descr=""/>
-          <p:cNvGraphicFramePr/>
-          <p:nvPr/>
-        </p:nvGraphicFramePr>
-        <p:xfrm>
-          <a:off x="457200" y="777240"/>
-          <a:ext cx="8229600" cy="3977640"/>
-        </p:xfrm>
-        <a:graphic xmlns:a="http://schemas.openxmlformats.org/drawingml/2006/main">
-          <a:graphicData uri="http://schemas.openxmlformats.org/drawingml/2006/chart">
-            <c:chart xmlns:c="http://schemas.openxmlformats.org/drawingml/2006/chart" r:id="rId1"/>
-          </a:graphicData>
-        </a:graphic>
-      </p:graphicFrame>
-      <p:sp>
-        <p:nvSpPr>
-          <p:cNvPr id="5" name="Text 2"/>
-          <p:cNvSpPr/>
-          <p:nvPr/>
-        </p:nvSpPr>
-        <p:spPr>
-          <a:xfrm>
-            <a:off x="457200" y="4828032"/>
-            <a:ext cx="3200400" cy="201168"/>
-          </a:xfrm>
-          <a:prstGeom prst="rect">
-            <a:avLst/>
-          </a:prstGeom>
-          <a:noFill/>
-          <a:ln/>
-        </p:spPr>
-        <p:txBody>
-          <a:bodyPr wrap="square" rtlCol="0" anchor="ctr"/>
-          <a:lstStyle/>
-          <a:p>
-            <a:pPr indent="0" marL="0">
-              <a:buNone/>
-            </a:pPr>
-            <a:r>
-              <a:rPr lang="en-US" sz="800" dirty="0">
-                <a:solidFill>
-                  <a:srgbClr val="000000"/>
-                </a:solidFill>
-                <a:latin typeface="맑은 고딕" pitchFamily="34" charset="0"/>
-                <a:ea typeface="맑은 고딕" pitchFamily="34" charset="-122"/>
-                <a:cs typeface="맑은 고딕" pitchFamily="34" charset="-120"/>
-              </a:rPr>
-              <a:t>── 1.0 (이상적 공정성)</a:t>
-            </a:r>
-            <a:endParaRPr lang="en-US" sz="800" dirty="0"/>
-          </a:p>
-        </p:txBody>
-      </p:sp>
     </p:spTree>
   </p:cSld>
   <p:clrMapOvr>

</xml_diff>

<commit_message>
Update final submission files and figures
- Updated presentation files: handout.pdf and presentation.pptx in both 07-presentation and 08-final-submission directories.
- Modified verify-submission.js to reflect changes in expected figure files, reducing the count from 11 to 9.
- Added new figures (fig-4-ollama-tier.pptx and fig-4-ollama-tier.png) and removed outdated figures (fig-4-mlfq-vs-fcfs.pptx and fig-5-ollama-tier.pptx).
- Updated manifest.yaml with new file sizes, modification times, and SHA256 checksums for various files.
- Adjusted the final report figures to include the new figures and remove the deleted ones.
</commit_message>
<xml_diff>
--- a/06-final-report/figures/final-figures.pptx
+++ b/06-final-report/figures/final-figures.pptx
@@ -9,10 +9,9 @@
     <p:sldId id="257" r:id="rId3"/>
     <p:sldId id="258" r:id="rId4"/>
     <p:sldId id="259" r:id="rId5"/>
-    <p:sldId id="260" r:id="rId6"/>
   </p:sldIdLst>
   <p:notesMasterIdLst>
-    <p:notesMasterId r:id="rId7"/>
+    <p:notesMasterId r:id="rId6"/>
   </p:notesMasterIdLst>
   <p:sldSz cx="12192000" cy="6858000"/>
   <p:notesSz cx="6858000" cy="12192000"/>
@@ -111,344 +110,7 @@
 </p:presentation>
 </file>
 
-<file path=ppt/charts/chart3.xml><?xml version="1.0" encoding="utf-8"?>
-<c:chartSpace xmlns:c="http://schemas.openxmlformats.org/drawingml/2006/chart" xmlns:a="http://schemas.openxmlformats.org/drawingml/2006/main" xmlns:r="http://schemas.openxmlformats.org/officeDocument/2006/relationships">
-  <c:date1904 val="0"/>
-  <c:roundedCorners val="1"/>
-  <c:chart>
-    <c:autoTitleDeleted val="1"/>
-    <c:plotArea>
-      <c:layout/>
-      <c:barChart>
-        <c:barDir val="col"/>
-        <c:grouping val="clustered"/>
-        <c:varyColors val="0"/>
-        <c:ser>
-          <c:idx val="0"/>
-          <c:order val="0"/>
-          <c:tx>
-            <c:strRef>
-              <c:f>Sheet1!$B$1</c:f>
-              <c:strCache>
-                <c:ptCount val="1"/>
-                <c:pt idx="0">
-                  <c:v>FCFS</c:v>
-                </c:pt>
-              </c:strCache>
-            </c:strRef>
-          </c:tx>
-          <c:spPr>
-            <a:solidFill>
-              <a:srgbClr val="CCCCCC"/>
-            </a:solidFill>
-            <a:effectLst/>
-          </c:spPr>
-          <c:invertIfNegative val="0"/>
-          <c:dLbls>
-            <c:numFmt formatCode="#,##0" sourceLinked="0"/>
-            <c:txPr>
-              <a:bodyPr/>
-              <a:lstStyle/>
-              <a:p>
-                <a:pPr>
-                  <a:defRPr b="0" i="0" strike="noStrike" sz="1000" u="none">
-                    <a:solidFill>
-                      <a:srgbClr val="000000"/>
-                    </a:solidFill>
-                    <a:latin typeface="Arial"/>
-                  </a:defRPr>
-                </a:pPr>
-              </a:p>
-            </c:txPr>
-            <c:showLegendKey val="0"/>
-            <c:showVal val="1"/>
-            <c:showCatName val="0"/>
-            <c:showSerName val="0"/>
-            <c:showPercent val="0"/>
-            <c:showBubbleSize val="0"/>
-            <c:showLeaderLines val="0"/>
-          </c:dLbls>
-          <c:cat>
-            <c:multiLvlStrRef>
-              <c:f>Sheet1!$A$2:$A$4</c:f>
-              <c:multiLvlStrCache>
-                <c:ptCount val="3"/>
-                <c:lvl>
-                  <c:pt idx="0">
-                    <c:v>짧은 요청 (Short)</c:v>
-                  </c:pt>
-                  <c:pt idx="1">
-                    <c:v>중간 요청 (Medium)</c:v>
-                  </c:pt>
-                  <c:pt idx="2">
-                    <c:v>긴 요청 (Long)</c:v>
-                  </c:pt>
-                </c:lvl>
-              </c:multiLvlStrCache>
-            </c:multiLvlStrRef>
-          </c:cat>
-          <c:val>
-            <c:numRef>
-              <c:f>Sheet1!$B$2:$B$4</c:f>
-              <c:numCache>
-                <c:formatCode>General</c:formatCode>
-                <c:ptCount val="3"/>
-                <c:pt idx="0">
-                  <c:v>635</c:v>
-                </c:pt>
-                <c:pt idx="1">
-                  <c:v>645</c:v>
-                </c:pt>
-                <c:pt idx="2">
-                  <c:v>650</c:v>
-                </c:pt>
-              </c:numCache>
-            </c:numRef>
-          </c:val>
-        </c:ser>
-        <c:ser>
-          <c:idx val="1"/>
-          <c:order val="1"/>
-          <c:tx>
-            <c:strRef>
-              <c:f>Sheet1!$C$1</c:f>
-              <c:strCache>
-                <c:ptCount val="1"/>
-                <c:pt idx="0">
-                  <c:v>MLFQ (선점형)</c:v>
-                </c:pt>
-              </c:strCache>
-            </c:strRef>
-          </c:tx>
-          <c:spPr>
-            <a:solidFill>
-              <a:srgbClr val="333333"/>
-            </a:solidFill>
-            <a:effectLst/>
-          </c:spPr>
-          <c:invertIfNegative val="0"/>
-          <c:dLbls>
-            <c:numFmt formatCode="#,##0" sourceLinked="0"/>
-            <c:txPr>
-              <a:bodyPr/>
-              <a:lstStyle/>
-              <a:p>
-                <a:pPr>
-                  <a:defRPr b="0" i="0" strike="noStrike" sz="1000" u="none">
-                    <a:solidFill>
-                      <a:srgbClr val="000000"/>
-                    </a:solidFill>
-                    <a:latin typeface="Arial"/>
-                  </a:defRPr>
-                </a:pPr>
-              </a:p>
-            </c:txPr>
-            <c:showLegendKey val="0"/>
-            <c:showVal val="1"/>
-            <c:showCatName val="0"/>
-            <c:showSerName val="0"/>
-            <c:showPercent val="0"/>
-            <c:showBubbleSize val="0"/>
-            <c:showLeaderLines val="0"/>
-          </c:dLbls>
-          <c:cat>
-            <c:multiLvlStrRef>
-              <c:f>Sheet1!$A$2:$A$4</c:f>
-              <c:multiLvlStrCache>
-                <c:ptCount val="3"/>
-                <c:lvl>
-                  <c:pt idx="0">
-                    <c:v>짧은 요청 (Short)</c:v>
-                  </c:pt>
-                  <c:pt idx="1">
-                    <c:v>중간 요청 (Medium)</c:v>
-                  </c:pt>
-                  <c:pt idx="2">
-                    <c:v>긴 요청 (Long)</c:v>
-                  </c:pt>
-                </c:lvl>
-              </c:multiLvlStrCache>
-            </c:multiLvlStrRef>
-          </c:cat>
-          <c:val>
-            <c:numRef>
-              <c:f>Sheet1!$C$2:$C$4</c:f>
-              <c:numCache>
-                <c:formatCode>General</c:formatCode>
-                <c:ptCount val="3"/>
-                <c:pt idx="0">
-                  <c:v>170</c:v>
-                </c:pt>
-                <c:pt idx="1">
-                  <c:v>729</c:v>
-                </c:pt>
-                <c:pt idx="2">
-                  <c:v>1226</c:v>
-                </c:pt>
-              </c:numCache>
-            </c:numRef>
-          </c:val>
-        </c:ser>
-        <c:dLbls>
-          <c:numFmt formatCode="#,##0" sourceLinked="0"/>
-          <c:txPr>
-            <a:bodyPr/>
-            <a:lstStyle/>
-            <a:p>
-              <a:pPr>
-                <a:defRPr b="0" i="0" strike="noStrike" sz="1000" u="none">
-                  <a:solidFill>
-                    <a:srgbClr val="000000"/>
-                  </a:solidFill>
-                  <a:latin typeface="Arial"/>
-                </a:defRPr>
-              </a:pPr>
-            </a:p>
-          </c:txPr>
-          <c:showLegendKey val="0"/>
-          <c:showVal val="1"/>
-          <c:showCatName val="0"/>
-          <c:showSerName val="0"/>
-          <c:showPercent val="0"/>
-          <c:showBubbleSize val="0"/>
-          <c:showLeaderLines val="0"/>
-        </c:dLbls>
-        <c:gapWidth val="150"/>
-        <c:overlap val="0"/>
-        <c:axId val="2094734554"/>
-        <c:axId val="2094734552"/>
-        <c:axId val="2094734556"/>
-      </c:barChart>
-      <c:catAx>
-        <c:axId val="2094734554"/>
-        <c:scaling>
-          <c:orientation val="minMax"/>
-        </c:scaling>
-        <c:delete val="0"/>
-        <c:axPos val="b"/>
-        <c:numFmt formatCode="General" sourceLinked="1"/>
-        <c:majorTickMark val="out"/>
-        <c:minorTickMark val="none"/>
-        <c:tickLblPos val="low"/>
-        <c:spPr>
-          <a:ln w="12700" cap="flat">
-            <a:solidFill>
-              <a:srgbClr val="888888"/>
-            </a:solidFill>
-            <a:prstDash val="solid"/>
-            <a:round/>
-          </a:ln>
-        </c:spPr>
-        <c:txPr>
-          <a:bodyPr/>
-          <a:lstStyle/>
-          <a:p>
-            <a:pPr>
-              <a:defRPr sz="1100" b="0" i="0" u="none" strike="noStrike">
-                <a:solidFill>
-                  <a:srgbClr val="000000"/>
-                </a:solidFill>
-                <a:latin typeface="Arial"/>
-              </a:defRPr>
-            </a:pPr>
-            <a:endParaRPr lang="en-US"/>
-          </a:p>
-        </c:txPr>
-        <c:crossAx val="2094734552"/>
-        <c:crosses val="autoZero"/>
-        <c:auto val="1"/>
-        <c:lblAlgn val="ctr"/>
-        <c:noMultiLvlLbl val="1"/>
-      </c:catAx>
-      <c:valAx>
-        <c:axId val="2094734552"/>
-        <c:scaling>
-          <c:orientation val="minMax"/>
-        </c:scaling>
-        <c:delete val="0"/>
-        <c:axPos val="l"/>
-        <c:majorGridlines>
-          <c:spPr>
-            <a:ln w="6350" cap="flat">
-              <a:solidFill>
-                <a:srgbClr val="DDDDDD"/>
-              </a:solidFill>
-              <a:prstDash val="dot"/>
-              <a:round/>
-            </a:ln>
-          </c:spPr>
-        </c:majorGridlines>
-        <c:numFmt formatCode="General" sourceLinked="0"/>
-        <c:majorTickMark val="out"/>
-        <c:minorTickMark val="none"/>
-        <c:tickLblPos val="nextTo"/>
-        <c:spPr>
-          <a:ln w="12700" cap="flat">
-            <a:solidFill>
-              <a:srgbClr val="888888"/>
-            </a:solidFill>
-            <a:prstDash val="solid"/>
-            <a:round/>
-          </a:ln>
-        </c:spPr>
-        <c:txPr>
-          <a:bodyPr/>
-          <a:lstStyle/>
-          <a:p>
-            <a:pPr>
-              <a:defRPr sz="900" b="0" i="0" u="none" strike="noStrike">
-                <a:solidFill>
-                  <a:srgbClr val="000000"/>
-                </a:solidFill>
-                <a:latin typeface="Arial"/>
-              </a:defRPr>
-            </a:pPr>
-            <a:endParaRPr lang="en-US"/>
-          </a:p>
-        </c:txPr>
-        <c:crossAx val="2094734554"/>
-        <c:crosses val="autoZero"/>
-        <c:crossBetween val="between"/>
-      </c:valAx>
-      <c:spPr>
-        <a:noFill/>
-        <a:ln>
-          <a:noFill/>
-        </a:ln>
-        <a:effectLst/>
-      </c:spPr>
-    </c:plotArea>
-    <c:legend>
-      <c:legendPos val="b"/>
-      <c:overlay val="0"/>
-      <c:txPr>
-        <a:bodyPr/>
-        <a:lstStyle/>
-        <a:p>
-          <a:pPr>
-            <a:defRPr sz="1000">      </a:defRPr>
-          </a:pPr>
-          <a:endParaRPr lang="en-US"/>
-        </a:p>
-      </c:txPr>
-    </c:legend>
-    <c:plotVisOnly val="1"/>
-    <c:dispBlanksAs val="span"/>
-  </c:chart>
-  <c:spPr>
-    <a:noFill/>
-    <a:ln>
-      <a:noFill/>
-    </a:ln>
-    <a:effectLst/>
-  </c:spPr>
-  <c:externalData r:id="rId1">
-    <c:autoUpdate val="0"/>
-  </c:externalData>
-</c:chartSpace>
-</file>
-
-<file path=ppt/charts/chart4.xml><?xml version="1.0" encoding="utf-8"?>
+<file path=ppt/charts/chart2.xml><?xml version="1.0" encoding="utf-8"?>
 <c:chartSpace xmlns:c="http://schemas.openxmlformats.org/drawingml/2006/chart" xmlns:a="http://schemas.openxmlformats.org/drawingml/2006/main" xmlns:r="http://schemas.openxmlformats.org/officeDocument/2006/relationships">
   <c:date1904 val="0"/>
   <c:roundedCorners val="1"/>
@@ -1587,94 +1249,6 @@
 </p:notes>
 </file>
 
-<file path=ppt/notesSlides/notesSlide5.xml><?xml version="1.0" encoding="utf-8"?>
-<p:notes xmlns:a="http://schemas.openxmlformats.org/drawingml/2006/main" xmlns:r="http://schemas.openxmlformats.org/officeDocument/2006/relationships" xmlns:p="http://schemas.openxmlformats.org/presentationml/2006/main">
-  <p:cSld>
-    <p:spTree>
-      <p:nvGrpSpPr>
-        <p:cNvPr id="1" name=""/>
-        <p:cNvGrpSpPr/>
-        <p:nvPr/>
-      </p:nvGrpSpPr>
-      <p:grpSpPr>
-        <a:xfrm>
-          <a:off x="0" y="0"/>
-          <a:ext cx="0" cy="0"/>
-          <a:chOff x="0" y="0"/>
-          <a:chExt cx="0" cy="0"/>
-        </a:xfrm>
-      </p:grpSpPr>
-      <p:sp>
-        <p:nvSpPr>
-          <p:cNvPr id="2" name="Slide Image Placeholder 1"/>
-          <p:cNvSpPr>
-            <a:spLocks noGrp="1" noRot="1" noChangeAspect="1"/>
-          </p:cNvSpPr>
-          <p:nvPr>
-            <p:ph type="sldImg"/>
-          </p:nvPr>
-        </p:nvSpPr>
-        <p:spPr/>
-      </p:sp>
-      <p:sp>
-        <p:nvSpPr>
-          <p:cNvPr id="3" name="Notes Placeholder 2"/>
-          <p:cNvSpPr>
-            <a:spLocks noGrp="1"/>
-          </p:cNvSpPr>
-          <p:nvPr>
-            <p:ph type="body" idx="1"/>
-          </p:nvPr>
-        </p:nvSpPr>
-        <p:spPr/>
-        <p:txBody>
-          <a:bodyPr/>
-          <a:lstStyle/>
-          <a:p>
-            <a:r>
-              <a:rPr lang="en-US" dirty="0"/>
-              <a:t/>
-            </a:r>
-            <a:endParaRPr lang="en-US" dirty="0"/>
-          </a:p>
-        </p:txBody>
-      </p:sp>
-      <p:sp>
-        <p:nvSpPr>
-          <p:cNvPr id="4" name="Slide Number Placeholder 3"/>
-          <p:cNvSpPr>
-            <a:spLocks noGrp="1"/>
-          </p:cNvSpPr>
-          <p:nvPr>
-            <p:ph type="sldNum" sz="quarter" idx="10"/>
-          </p:nvPr>
-        </p:nvSpPr>
-        <p:spPr/>
-        <p:txBody>
-          <a:bodyPr/>
-          <a:lstStyle/>
-          <a:p>
-            <a:fld id="{F7021451-1387-4CA6-816F-3879F97B5CBC}" type="slidenum">
-              <a:rPr lang="en-US"/>
-              <a:t>5</a:t>
-            </a:fld>
-            <a:endParaRPr lang="en-US"/>
-          </a:p>
-        </p:txBody>
-      </p:sp>
-    </p:spTree>
-    <p:extLst>
-      <p:ext uri="{BB962C8B-B14F-4D97-AF65-F5344CB8AC3E}">
-        <p14:creationId xmlns:p14="http://schemas.microsoft.com/office/powerpoint/2010/main" val="1024086991"/>
-      </p:ext>
-    </p:extLst>
-  </p:cSld>
-  <p:clrMapOvr>
-    <a:masterClrMapping/>
-  </p:clrMapOvr>
-</p:notes>
-</file>
-
 <file path=ppt/slideLayouts/slideLayout1.xml><?xml version="1.0" encoding="utf-8"?>
 <p:sldLayout xmlns:a="http://schemas.openxmlformats.org/drawingml/2006/main" xmlns:r="http://schemas.openxmlformats.org/officeDocument/2006/relationships" xmlns:p="http://schemas.openxmlformats.org/presentationml/2006/main" preserve="1">
   <p:cSld name="DEFAULT">
@@ -6347,126 +5921,7 @@
                 <a:ea typeface="맑은 고딕" pitchFamily="34" charset="-122"/>
                 <a:cs typeface="맑은 고딕" pitchFamily="34" charset="-120"/>
               </a:rPr>
-              <a:t>그림 4. MLFQ 선점형 vs FCFS — 요청 유형별 응답시간</a:t>
-            </a:r>
-            <a:endParaRPr lang="en-US" sz="1400" dirty="0"/>
-          </a:p>
-        </p:txBody>
-      </p:sp>
-      <p:sp>
-        <p:nvSpPr>
-          <p:cNvPr id="3" name="Text 1"/>
-          <p:cNvSpPr/>
-          <p:nvPr/>
-        </p:nvSpPr>
-        <p:spPr>
-          <a:xfrm>
-            <a:off x="274320" y="475488"/>
-            <a:ext cx="8595360" cy="228600"/>
-          </a:xfrm>
-          <a:prstGeom prst="rect">
-            <a:avLst/>
-          </a:prstGeom>
-          <a:noFill/>
-          <a:ln/>
-        </p:spPr>
-        <p:txBody>
-          <a:bodyPr wrap="square" rtlCol="0" anchor="ctr"/>
-          <a:lstStyle/>
-          <a:p>
-            <a:pPr indent="0" marL="0">
-              <a:buNone/>
-            </a:pPr>
-            <a:r>
-              <a:rPr lang="en-US" sz="900" dirty="0">
-                <a:solidFill>
-                  <a:srgbClr val="333333"/>
-                </a:solidFill>
-                <a:latin typeface="맑은 고딕" pitchFamily="34" charset="0"/>
-                <a:ea typeface="맑은 고딕" pitchFamily="34" charset="-122"/>
-                <a:cs typeface="맑은 고딕" pitchFamily="34" charset="-120"/>
-              </a:rPr>
-              <a:t>5시드 평균 | 버스트 패턴 | 단위: 초(s)</a:t>
-            </a:r>
-            <a:endParaRPr lang="en-US" sz="900" dirty="0"/>
-          </a:p>
-        </p:txBody>
-      </p:sp>
-      <p:graphicFrame>
-        <p:nvGraphicFramePr>
-          <p:cNvPr id="4" name="Chart 0" descr=""/>
-          <p:cNvGraphicFramePr/>
-          <p:nvPr/>
-        </p:nvGraphicFramePr>
-        <p:xfrm>
-          <a:off x="457200" y="777240"/>
-          <a:ext cx="7772400" cy="3977640"/>
-        </p:xfrm>
-        <a:graphic xmlns:a="http://schemas.openxmlformats.org/drawingml/2006/main">
-          <a:graphicData uri="http://schemas.openxmlformats.org/drawingml/2006/chart">
-            <c:chart xmlns:c="http://schemas.openxmlformats.org/drawingml/2006/chart" r:id="rId1"/>
-          </a:graphicData>
-        </a:graphic>
-      </p:graphicFrame>
-    </p:spTree>
-  </p:cSld>
-  <p:clrMapOvr>
-    <a:masterClrMapping/>
-  </p:clrMapOvr>
-</p:sld>
-</file>
-
-<file path=ppt/slides/slide5.xml><?xml version="1.0" encoding="utf-8"?>
-<p:sld xmlns:a="http://schemas.openxmlformats.org/drawingml/2006/main" xmlns:r="http://schemas.openxmlformats.org/officeDocument/2006/relationships" xmlns:p="http://schemas.openxmlformats.org/presentationml/2006/main">
-  <p:cSld name="Slide 5">
-    <p:spTree>
-      <p:nvGrpSpPr>
-        <p:cNvPr id="1" name=""/>
-        <p:cNvGrpSpPr/>
-        <p:nvPr/>
-      </p:nvGrpSpPr>
-      <p:grpSpPr>
-        <a:xfrm>
-          <a:off x="0" y="0"/>
-          <a:ext cx="0" cy="0"/>
-          <a:chOff x="0" y="0"/>
-          <a:chExt cx="0" cy="0"/>
-        </a:xfrm>
-      </p:grpSpPr>
-      <p:sp>
-        <p:nvSpPr>
-          <p:cNvPr id="2" name="Text 0"/>
-          <p:cNvSpPr/>
-          <p:nvPr/>
-        </p:nvSpPr>
-        <p:spPr>
-          <a:xfrm>
-            <a:off x="274320" y="91440"/>
-            <a:ext cx="8595360" cy="411480"/>
-          </a:xfrm>
-          <a:prstGeom prst="rect">
-            <a:avLst/>
-          </a:prstGeom>
-          <a:noFill/>
-          <a:ln/>
-        </p:spPr>
-        <p:txBody>
-          <a:bodyPr wrap="square" rtlCol="0" anchor="ctr"/>
-          <a:lstStyle/>
-          <a:p>
-            <a:pPr algn="ctr" indent="0" marL="0">
-              <a:buNone/>
-            </a:pPr>
-            <a:r>
-              <a:rPr lang="en-US" sz="1400" b="1" dirty="0">
-                <a:solidFill>
-                  <a:srgbClr val="000000"/>
-                </a:solidFill>
-                <a:latin typeface="맑은 고딕" pitchFamily="34" charset="0"/>
-                <a:ea typeface="맑은 고딕" pitchFamily="34" charset="-122"/>
-                <a:cs typeface="맑은 고딕" pitchFamily="34" charset="-120"/>
-              </a:rPr>
-              <a:t>그림 5. 실서버 구독 등급별 평균 대기시간 (ms)</a:t>
+              <a:t>그림 4. 실서버 구독 등급별 평균 대기시간 (ms)</a:t>
             </a:r>
             <a:endParaRPr lang="en-US" sz="1400" dirty="0"/>
           </a:p>

</xml_diff>